<commit_message>
chore(release): bump version to 2.1.0, update .gitignore and finalize presentation assets
</commit_message>
<xml_diff>
--- a/FUSION_HIGH_SYSTEM_PRESENTATION.pptx
+++ b/FUSION_HIGH_SYSTEM_PRESENTATION.pptx
@@ -4,6 +4,9 @@
   <p:sldMasterIdLst>
     <p:sldMasterId id="2147483648" r:id="rId1"/>
   </p:sldMasterIdLst>
+  <p:notesMasterIdLst>
+    <p:notesMasterId r:id="rId20"/>
+  </p:notesMasterIdLst>
   <p:sldIdLst>
     <p:sldId id="256" r:id="rId2"/>
     <p:sldId id="257" r:id="rId3"/>
@@ -24,10 +27,7 @@
     <p:sldId id="272" r:id="rId18"/>
     <p:sldId id="273" r:id="rId19"/>
   </p:sldIdLst>
-  <p:notesMasterIdLst>
-    <p:notesMasterId r:id="rId20"/>
-  </p:notesMasterIdLst>
-  <p:sldSz cx="9144000" cy="5143500"/>
+  <p:sldSz cx="9144000" cy="5143500" type="screen16x9"/>
   <p:notesSz cx="5143500" cy="9144000"/>
   <p:defaultTextStyle>
     <a:lvl1pPr marL="0" algn="l" defTabSz="914400" rtl="0" eaLnBrk="1" latinLnBrk="0" hangingPunct="1">
@@ -121,6 +121,11 @@
       </a:defRPr>
     </a:lvl9pPr>
   </p:defaultTextStyle>
+  <p:extLst>
+    <p:ext uri="{EFAFB233-063F-42B5-8137-9DF3F51BA10A}">
+      <p15:sldGuideLst xmlns:p15="http://schemas.microsoft.com/office/powerpoint/2012/main"/>
+    </p:ext>
+  </p:extLst>
 </p:presentation>
 </file>
 
@@ -146,234 +151,10 @@
           <a:chExt cx="0" cy="0"/>
         </a:xfrm>
       </p:grpSpPr>
-      <p:sp>
-        <p:nvSpPr>
-          <p:cNvPr id="2" name="Header Placeholder 1"/>
-          <p:cNvSpPr>
-            <a:spLocks noGrp="1"/>
-          </p:cNvSpPr>
-          <p:nvPr>
-            <p:ph type="hdr" sz="quarter"/>
-          </p:nvPr>
-        </p:nvSpPr>
-        <p:spPr>
-          <a:xfrm>
-            <a:off x="0" y="0"/>
-            <a:ext cx="2971800" cy="458788"/>
-          </a:xfrm>
-          <a:prstGeom prst="rect">
-            <a:avLst/>
-          </a:prstGeom>
-        </p:spPr>
-        <p:txBody>
-          <a:bodyPr vert="horz" lIns="91440" tIns="45720" rIns="91440" bIns="45720" rtlCol="0"/>
-          <a:lstStyle>
-            <a:lvl1pPr algn="l">
-              <a:defRPr sz="1200"/>
-            </a:lvl1pPr>
-          </a:lstStyle>
-          <a:p>
-            <a:endParaRPr lang="en-US"/>
-          </a:p>
-        </p:txBody>
-      </p:sp>
-      <p:sp>
-        <p:nvSpPr>
-          <p:cNvPr id="3" name="Date Placeholder 2"/>
-          <p:cNvSpPr>
-            <a:spLocks noGrp="1"/>
-          </p:cNvSpPr>
-          <p:nvPr>
-            <p:ph type="dt" idx="1"/>
-          </p:nvPr>
-        </p:nvSpPr>
-        <p:spPr>
-          <a:xfrm>
-            <a:off x="3884613" y="0"/>
-            <a:ext cx="2971800" cy="458788"/>
-          </a:xfrm>
-          <a:prstGeom prst="rect">
-            <a:avLst/>
-          </a:prstGeom>
-        </p:spPr>
-        <p:txBody>
-          <a:bodyPr vert="horz" lIns="91440" tIns="45720" rIns="91440" bIns="45720" rtlCol="0"/>
-          <a:lstStyle>
-            <a:lvl1pPr algn="r">
-              <a:defRPr sz="1200"/>
-            </a:lvl1pPr>
-          </a:lstStyle>
-          <a:p>
-            <a:fld id="{5282F153-3F37-0F45-9E97-73ACFA13230C}" type="datetimeFigureOut">
-              <a:rPr lang="en-US"/>
-              <a:t>7/23/19</a:t>
-            </a:fld>
-            <a:endParaRPr lang="en-US"/>
-          </a:p>
-        </p:txBody>
-      </p:sp>
-      <p:sp>
-        <p:nvSpPr>
-          <p:cNvPr id="4" name="Slide Image Placeholder 3"/>
-          <p:cNvSpPr>
-            <a:spLocks noGrp="1" noRot="1" noChangeAspect="1"/>
-          </p:cNvSpPr>
-          <p:nvPr>
-            <p:ph type="sldImg" idx="2"/>
-          </p:nvPr>
-        </p:nvSpPr>
-        <p:spPr>
-          <a:xfrm>
-            <a:off x="685800" y="1143000"/>
-            <a:ext cx="5486400" cy="3086100"/>
-          </a:xfrm>
-          <a:prstGeom prst="rect">
-            <a:avLst/>
-          </a:prstGeom>
-          <a:noFill/>
-          <a:ln w="12700">
-            <a:solidFill>
-              <a:prstClr val="black"/>
-            </a:solidFill>
-          </a:ln>
-        </p:spPr>
-        <p:txBody>
-          <a:bodyPr vert="horz" lIns="91440" tIns="45720" rIns="91440" bIns="45720" rtlCol="0" anchor="ctr"/>
-          <a:lstStyle/>
-          <a:p>
-            <a:endParaRPr lang="en-US"/>
-          </a:p>
-        </p:txBody>
-      </p:sp>
-      <p:sp>
-        <p:nvSpPr>
-          <p:cNvPr id="5" name="Notes Placeholder 4"/>
-          <p:cNvSpPr>
-            <a:spLocks noGrp="1"/>
-          </p:cNvSpPr>
-          <p:nvPr>
-            <p:ph type="body" sz="quarter" idx="3"/>
-          </p:nvPr>
-        </p:nvSpPr>
-        <p:spPr>
-          <a:xfrm>
-            <a:off x="685800" y="4400550"/>
-            <a:ext cx="5486400" cy="3600450"/>
-          </a:xfrm>
-          <a:prstGeom prst="rect">
-            <a:avLst/>
-          </a:prstGeom>
-        </p:spPr>
-        <p:txBody>
-          <a:bodyPr vert="horz" lIns="91440" tIns="45720" rIns="91440" bIns="45720" rtlCol="0"/>
-          <a:lstStyle/>
-          <a:p>
-            <a:pPr lvl="0"/>
-            <a:r>
-              <a:rPr lang="en-US"/>
-              <a:t>Click to edit Master text styles</a:t>
-            </a:r>
-          </a:p>
-          <a:p>
-            <a:pPr lvl="1"/>
-            <a:r>
-              <a:rPr lang="en-US"/>
-              <a:t>Second level</a:t>
-            </a:r>
-          </a:p>
-          <a:p>
-            <a:pPr lvl="2"/>
-            <a:r>
-              <a:rPr lang="en-US"/>
-              <a:t>Third level</a:t>
-            </a:r>
-          </a:p>
-          <a:p>
-            <a:pPr lvl="3"/>
-            <a:r>
-              <a:rPr lang="en-US"/>
-              <a:t>Fourth level</a:t>
-            </a:r>
-          </a:p>
-          <a:p>
-            <a:pPr lvl="4"/>
-            <a:r>
-              <a:rPr lang="en-US"/>
-              <a:t>Fifth level</a:t>
-            </a:r>
-          </a:p>
-        </p:txBody>
-      </p:sp>
-      <p:sp>
-        <p:nvSpPr>
-          <p:cNvPr id="6" name="Footer Placeholder 5"/>
-          <p:cNvSpPr>
-            <a:spLocks noGrp="1"/>
-          </p:cNvSpPr>
-          <p:nvPr>
-            <p:ph type="ftr" sz="quarter" idx="4"/>
-          </p:nvPr>
-        </p:nvSpPr>
-        <p:spPr>
-          <a:xfrm>
-            <a:off x="0" y="8685213"/>
-            <a:ext cx="2971800" cy="458787"/>
-          </a:xfrm>
-          <a:prstGeom prst="rect">
-            <a:avLst/>
-          </a:prstGeom>
-        </p:spPr>
-        <p:txBody>
-          <a:bodyPr vert="horz" lIns="91440" tIns="45720" rIns="91440" bIns="45720" rtlCol="0" anchor="b"/>
-          <a:lstStyle>
-            <a:lvl1pPr algn="l">
-              <a:defRPr sz="1200"/>
-            </a:lvl1pPr>
-          </a:lstStyle>
-          <a:p>
-            <a:endParaRPr lang="en-US"/>
-          </a:p>
-        </p:txBody>
-      </p:sp>
-      <p:sp>
-        <p:nvSpPr>
-          <p:cNvPr id="7" name="Slide Number Placeholder 6"/>
-          <p:cNvSpPr>
-            <a:spLocks noGrp="1"/>
-          </p:cNvSpPr>
-          <p:nvPr>
-            <p:ph type="sldNum" sz="quarter" idx="5"/>
-          </p:nvPr>
-        </p:nvSpPr>
-        <p:spPr>
-          <a:xfrm>
-            <a:off x="3884613" y="8685213"/>
-            <a:ext cx="2971800" cy="458787"/>
-          </a:xfrm>
-          <a:prstGeom prst="rect">
-            <a:avLst/>
-          </a:prstGeom>
-        </p:spPr>
-        <p:txBody>
-          <a:bodyPr vert="horz" lIns="91440" tIns="45720" rIns="91440" bIns="45720" rtlCol="0" anchor="b"/>
-          <a:lstStyle>
-            <a:lvl1pPr algn="r">
-              <a:defRPr sz="1200"/>
-            </a:lvl1pPr>
-          </a:lstStyle>
-          <a:p>
-            <a:fld id="{CE5E9CC1-C706-0F49-92D6-E571CC5EEA8F}" type="slidenum">
-              <a:rPr lang="en-US"/>
-              <a:t>‹#›</a:t>
-            </a:fld>
-            <a:endParaRPr lang="en-US"/>
-          </a:p>
-        </p:txBody>
-      </p:sp>
     </p:spTree>
     <p:extLst>
       <p:ext uri="{BB962C8B-B14F-4D97-AF65-F5344CB8AC3E}">
-        <p14:creationId xmlns:p14="http://schemas.microsoft.com/office/powerpoint/2010/main" val="1024086991"/>
+        <p14:creationId xmlns:p14="http://schemas.microsoft.com/office/powerpoint/2010/main" val="792342537"/>
       </p:ext>
     </p:extLst>
   </p:cSld>
@@ -517,10 +298,6 @@
           <a:bodyPr/>
           <a:lstStyle/>
           <a:p>
-            <a:r>
-              <a:rPr lang="en-US" dirty="0"/>
-              <a:t/>
-            </a:r>
             <a:endParaRPr lang="en-US" dirty="0"/>
           </a:p>
         </p:txBody>
@@ -609,7 +386,6 @@
               <a:rPr lang="en-US" dirty="0"/>
               <a:t>Reiterate that each school maintains its own distinct timetable schedule tailored to its faculty and classroom facilities.</a:t>
             </a:r>
-            <a:endParaRPr lang="en-US" dirty="0"/>
           </a:p>
         </p:txBody>
       </p:sp>
@@ -697,7 +473,6 @@
               <a:rPr lang="en-US" dirty="0"/>
               <a:t>Highlight how parents can inspect fee statements transparently and receive automated reminders without manual accounting bottlenecks.</a:t>
             </a:r>
-            <a:endParaRPr lang="en-US" dirty="0"/>
           </a:p>
         </p:txBody>
       </p:sp>
@@ -785,7 +560,6 @@
               <a:rPr lang="en-US" dirty="0"/>
               <a:t>Discuss how high schools in Limpopo and Gauteng can boost their provincial matric rankings through predictive diagnostics.</a:t>
             </a:r>
-            <a:endParaRPr lang="en-US" dirty="0"/>
           </a:p>
         </p:txBody>
       </p:sp>
@@ -873,7 +647,6 @@
               <a:rPr lang="en-US" dirty="0"/>
               <a:t>Show how schools eliminate unsupervised classrooms by automatically matching relief educators during staff absence.</a:t>
             </a:r>
-            <a:endParaRPr lang="en-US" dirty="0"/>
           </a:p>
         </p:txBody>
       </p:sp>
@@ -961,7 +734,6 @@
               <a:rPr lang="en-US" dirty="0"/>
               <a:t>Emphasize the social impact: unlocking university funding for learners based on their actual academic performance.</a:t>
             </a:r>
-            <a:endParaRPr lang="en-US" dirty="0"/>
           </a:p>
         </p:txBody>
       </p:sp>
@@ -1049,7 +821,6 @@
               <a:rPr lang="en-US" dirty="0"/>
               <a:t>Explain that the AI acts as an educator representing the learner's own school, strictly adhering to the CAPS curriculum without mentioning external AI brand names.</a:t>
             </a:r>
-            <a:endParaRPr lang="en-US" dirty="0"/>
           </a:p>
         </p:txBody>
       </p:sp>
@@ -1137,7 +908,6 @@
               <a:rPr lang="en-US" dirty="0"/>
               <a:t>Walk through the textbook distribution and return workflows that minimize learning material losses across academic years.</a:t>
             </a:r>
-            <a:endParaRPr lang="en-US" dirty="0"/>
           </a:p>
         </p:txBody>
       </p:sp>
@@ -1221,10 +991,6 @@
           <a:bodyPr/>
           <a:lstStyle/>
           <a:p>
-            <a:r>
-              <a:rPr lang="en-US" dirty="0"/>
-              <a:t/>
-            </a:r>
             <a:endParaRPr lang="en-US" dirty="0"/>
           </a:p>
         </p:txBody>
@@ -1309,10 +1075,6 @@
           <a:bodyPr/>
           <a:lstStyle/>
           <a:p>
-            <a:r>
-              <a:rPr lang="en-US" dirty="0"/>
-              <a:t/>
-            </a:r>
             <a:endParaRPr lang="en-US" dirty="0"/>
           </a:p>
         </p:txBody>
@@ -1397,10 +1159,6 @@
           <a:bodyPr/>
           <a:lstStyle/>
           <a:p>
-            <a:r>
-              <a:rPr lang="en-US" dirty="0"/>
-              <a:t/>
-            </a:r>
             <a:endParaRPr lang="en-US" dirty="0"/>
           </a:p>
         </p:txBody>
@@ -1489,7 +1247,6 @@
               <a:rPr lang="en-US" dirty="0"/>
               <a:t>Explain that the home page provides public visibility while allowing prospective learners and parents to select their respective school for immediate application.</a:t>
             </a:r>
-            <a:endParaRPr lang="en-US" dirty="0"/>
           </a:p>
         </p:txBody>
       </p:sp>
@@ -1577,7 +1334,6 @@
               <a:rPr lang="en-US" dirty="0"/>
               <a:t>Highlight how the Main Executive Administrator has comprehensive cross-institution oversight while ensuring dedicated SubAdmins manage their own individual schools.</a:t>
             </a:r>
-            <a:endParaRPr lang="en-US" dirty="0"/>
           </a:p>
         </p:txBody>
       </p:sp>
@@ -1665,7 +1421,6 @@
               <a:rPr lang="en-US" dirty="0"/>
               <a:t>Walk through the appointment workflow: selecting the school, entering educator details, and dispatching automated credentials directly to their email.</a:t>
             </a:r>
-            <a:endParaRPr lang="en-US" dirty="0"/>
           </a:p>
         </p:txBody>
       </p:sp>
@@ -1753,7 +1508,6 @@
               <a:rPr lang="en-US" dirty="0"/>
               <a:t>Emphasize that this module brings fun and collaboration across schools, allowing students and teachers from all institutions to follow match days and standings.</a:t>
             </a:r>
-            <a:endParaRPr lang="en-US" dirty="0"/>
           </a:p>
         </p:txBody>
       </p:sp>
@@ -1841,7 +1595,6 @@
               <a:rPr lang="en-US" dirty="0"/>
               <a:t>Demonstrate how parents can schedule targeted 20-minute reviews with subject teachers to discuss academic progress, test preparations, and intervention strategies.</a:t>
             </a:r>
-            <a:endParaRPr lang="en-US" dirty="0"/>
           </a:p>
         </p:txBody>
       </p:sp>
@@ -1929,7 +1682,6 @@
               <a:rPr lang="en-US" dirty="0"/>
               <a:t>Show how the system turns raw term test marks into official, signed DBE-compliant academic certificates ready for parent inspection.</a:t>
             </a:r>
-            <a:endParaRPr lang="en-US" dirty="0"/>
           </a:p>
         </p:txBody>
       </p:sp>
@@ -2017,7 +1769,6 @@
               <a:rPr lang="en-US" dirty="0"/>
               <a:t>Explain the assessment moderation workflow and how subject heads verify teacher marking standards.</a:t>
             </a:r>
-            <a:endParaRPr lang="en-US" dirty="0"/>
           </a:p>
         </p:txBody>
       </p:sp>
@@ -2090,6 +1841,11 @@
 <file path=ppt/slideMasters/slideMaster1.xml><?xml version="1.0" encoding="utf-8"?>
 <p:sldMaster xmlns:a="http://schemas.openxmlformats.org/drawingml/2006/main" xmlns:r="http://schemas.openxmlformats.org/officeDocument/2006/relationships" xmlns:p="http://schemas.openxmlformats.org/presentationml/2006/main">
   <p:cSld>
+    <p:bg>
+      <p:bgRef idx="1001">
+        <a:schemeClr val="bg1"/>
+      </p:bgRef>
+    </p:bg>
     <p:spTree>
       <p:nvGrpSpPr>
         <p:cNvPr id="1" name=""/>
@@ -2372,6 +2128,7 @@
         <a:solidFill>
           <a:srgbClr val="0B0F19"/>
         </a:solidFill>
+        <a:effectLst/>
       </p:bgPr>
     </p:bg>
     <p:spTree>
@@ -2396,8 +2153,8 @@
         </p:nvSpPr>
         <p:spPr>
           <a:xfrm>
-            <a:off x="731520" y="731520"/>
-            <a:ext cx="10698480" cy="365760"/>
+            <a:off x="0" y="731520"/>
+            <a:ext cx="9144000" cy="365760"/>
           </a:xfrm>
           <a:prstGeom prst="rect">
             <a:avLst/>
@@ -2407,6 +2164,13 @@
           </a:solidFill>
           <a:ln/>
         </p:spPr>
+        <p:txBody>
+          <a:bodyPr/>
+          <a:lstStyle/>
+          <a:p>
+            <a:endParaRPr lang="en-US" dirty="0"/>
+          </a:p>
+        </p:txBody>
       </p:sp>
       <p:sp>
         <p:nvSpPr>
@@ -2416,8 +2180,8 @@
         </p:nvSpPr>
         <p:spPr>
           <a:xfrm>
-            <a:off x="731520" y="1371600"/>
-            <a:ext cx="10698480" cy="1097280"/>
+            <a:off x="0" y="1371600"/>
+            <a:ext cx="9144000" cy="1097280"/>
           </a:xfrm>
           <a:prstGeom prst="rect">
             <a:avLst/>
@@ -2429,7 +2193,7 @@
           <a:bodyPr wrap="square" rtlCol="0" anchor="ctr"/>
           <a:lstStyle/>
           <a:p>
-            <a:pPr indent="0" marL="0">
+            <a:pPr marL="0" indent="0">
               <a:buNone/>
             </a:pPr>
             <a:r>
@@ -2456,7 +2220,7 @@
         <p:spPr>
           <a:xfrm>
             <a:off x="731520" y="2560320"/>
-            <a:ext cx="10698480" cy="731520"/>
+            <a:ext cx="8260080" cy="731520"/>
           </a:xfrm>
           <a:prstGeom prst="rect">
             <a:avLst/>
@@ -2468,7 +2232,7 @@
           <a:bodyPr wrap="square" rtlCol="0" anchor="ctr"/>
           <a:lstStyle/>
           <a:p>
-            <a:pPr indent="0" marL="0">
+            <a:pPr marL="0" indent="0">
               <a:buNone/>
             </a:pPr>
             <a:r>
@@ -2494,8 +2258,8 @@
         </p:nvSpPr>
         <p:spPr>
           <a:xfrm>
-            <a:off x="731520" y="3840480"/>
-            <a:ext cx="10698480" cy="1828800"/>
+            <a:off x="0" y="3291840"/>
+            <a:ext cx="9144000" cy="1851660"/>
           </a:xfrm>
           <a:prstGeom prst="rect">
             <a:avLst/>
@@ -2507,7 +2271,7 @@
           <a:bodyPr wrap="square" rtlCol="0" anchor="ctr"/>
           <a:lstStyle/>
           <a:p>
-            <a:pPr indent="0" marL="0">
+            <a:pPr marL="0" indent="0">
               <a:lnSpc>
                 <a:spcPts val="2200"/>
               </a:lnSpc>
@@ -2521,12 +2285,6 @@
               </a:rPr>
               <a:t>Presenter: </a:t>
             </a:r>
-            <a:pPr indent="0" marL="0">
-              <a:lnSpc>
-                <a:spcPts val="2200"/>
-              </a:lnSpc>
-              <a:buNone/>
-            </a:pPr>
             <a:r>
               <a:rPr lang="en-US" sz="1300" dirty="0">
                 <a:solidFill>
@@ -2536,12 +2294,6 @@
               <a:t>Executive School Leadership &amp; Systems Architecture Team
 </a:t>
             </a:r>
-            <a:pPr indent="0" marL="0">
-              <a:lnSpc>
-                <a:spcPts val="2200"/>
-              </a:lnSpc>
-              <a:buNone/>
-            </a:pPr>
             <a:r>
               <a:rPr lang="en-US" sz="1300" b="1" dirty="0">
                 <a:solidFill>
@@ -2550,12 +2302,6 @@
               </a:rPr>
               <a:t>Territory Coverage: </a:t>
             </a:r>
-            <a:pPr indent="0" marL="0">
-              <a:lnSpc>
-                <a:spcPts val="2200"/>
-              </a:lnSpc>
-              <a:buNone/>
-            </a:pPr>
             <a:r>
               <a:rPr lang="en-US" sz="1300" dirty="0">
                 <a:solidFill>
@@ -2565,12 +2311,6 @@
               <a:t>Limpopo (Capricorn South / Mankweng) &amp; Gauteng (Tshwane Districts)
 </a:t>
             </a:r>
-            <a:pPr indent="0" marL="0">
-              <a:lnSpc>
-                <a:spcPts val="2200"/>
-              </a:lnSpc>
-              <a:buNone/>
-            </a:pPr>
             <a:r>
               <a:rPr lang="en-US" sz="1300" b="1" dirty="0">
                 <a:solidFill>
@@ -2579,19 +2319,13 @@
               </a:rPr>
               <a:t>Academic Standard: </a:t>
             </a:r>
-            <a:pPr indent="0" marL="0">
-              <a:lnSpc>
-                <a:spcPts val="2200"/>
-              </a:lnSpc>
-              <a:buNone/>
-            </a:pPr>
             <a:r>
               <a:rPr lang="en-US" sz="1300" dirty="0">
                 <a:solidFill>
                   <a:srgbClr val="F8FAFC"/>
                 </a:solidFill>
               </a:rPr>
-              <a:t>South African Department of Basic Education (CAPS &amp; SASAMS Aligned)</a:t>
+              <a:t>South African Department of Basic Education (CAPS Aligned)</a:t>
             </a:r>
             <a:endParaRPr lang="en-US" sz="1300" dirty="0"/>
           </a:p>
@@ -2613,6 +2347,7 @@
         <a:solidFill>
           <a:srgbClr val="0B0F19"/>
         </a:solidFill>
+        <a:effectLst/>
       </p:bgPr>
     </p:bg>
     <p:spTree>
@@ -2648,6 +2383,13 @@
           </a:solidFill>
           <a:ln/>
         </p:spPr>
+        <p:txBody>
+          <a:bodyPr/>
+          <a:lstStyle/>
+          <a:p>
+            <a:endParaRPr lang="en-US"/>
+          </a:p>
+        </p:txBody>
       </p:sp>
       <p:sp>
         <p:nvSpPr>
@@ -2670,7 +2412,7 @@
           <a:bodyPr wrap="square" rtlCol="0" anchor="ctr"/>
           <a:lstStyle/>
           <a:p>
-            <a:pPr indent="0" marL="0">
+            <a:pPr marL="0" indent="0">
               <a:buNone/>
             </a:pPr>
             <a:r>
@@ -2706,7 +2448,7 @@
           <a:bodyPr wrap="square" rtlCol="0" anchor="ctr"/>
           <a:lstStyle/>
           <a:p>
-            <a:pPr indent="0" marL="0">
+            <a:pPr marL="0" indent="0">
               <a:buNone/>
             </a:pPr>
             <a:r>
@@ -2747,6 +2489,13 @@
             <a:prstDash val="solid"/>
           </a:ln>
         </p:spPr>
+        <p:txBody>
+          <a:bodyPr/>
+          <a:lstStyle/>
+          <a:p>
+            <a:endParaRPr lang="en-US"/>
+          </a:p>
+        </p:txBody>
       </p:sp>
       <p:sp>
         <p:nvSpPr>
@@ -2769,7 +2518,7 @@
           <a:bodyPr wrap="square" rtlCol="0" anchor="ctr"/>
           <a:lstStyle/>
           <a:p>
-            <a:pPr indent="0" marL="0">
+            <a:pPr marL="0" indent="0">
               <a:buNone/>
             </a:pPr>
             <a:r>
@@ -2805,7 +2554,7 @@
           <a:bodyPr wrap="square" rtlCol="0" anchor="ctr"/>
           <a:lstStyle/>
           <a:p>
-            <a:pPr indent="0" marL="0">
+            <a:pPr marL="0" indent="0">
               <a:lnSpc>
                 <a:spcPts val="1600"/>
               </a:lnSpc>
@@ -2822,16 +2571,16 @@
             <a:endParaRPr lang="en-US" sz="1100" dirty="0"/>
           </a:p>
           <a:p>
-            <a:pPr indent="0" marL="0">
-              <a:lnSpc>
-                <a:spcPts val="1600"/>
-              </a:lnSpc>
-              <a:buNone/>
-            </a:pPr>
-            <a:endParaRPr lang="en-US" sz="1100" dirty="0"/>
-          </a:p>
-          <a:p>
-            <a:pPr indent="0" marL="0">
+            <a:pPr marL="0" indent="0">
+              <a:lnSpc>
+                <a:spcPts val="1600"/>
+              </a:lnSpc>
+              <a:buNone/>
+            </a:pPr>
+            <a:endParaRPr lang="en-US" sz="1100" dirty="0"/>
+          </a:p>
+          <a:p>
+            <a:pPr marL="0" indent="0">
               <a:lnSpc>
                 <a:spcPts val="1600"/>
               </a:lnSpc>
@@ -2848,16 +2597,16 @@
             <a:endParaRPr lang="en-US" sz="1100" dirty="0"/>
           </a:p>
           <a:p>
-            <a:pPr indent="0" marL="0">
-              <a:lnSpc>
-                <a:spcPts val="1600"/>
-              </a:lnSpc>
-              <a:buNone/>
-            </a:pPr>
-            <a:endParaRPr lang="en-US" sz="1100" dirty="0"/>
-          </a:p>
-          <a:p>
-            <a:pPr indent="0" marL="0">
+            <a:pPr marL="0" indent="0">
+              <a:lnSpc>
+                <a:spcPts val="1600"/>
+              </a:lnSpc>
+              <a:buNone/>
+            </a:pPr>
+            <a:endParaRPr lang="en-US" sz="1100" dirty="0"/>
+          </a:p>
+          <a:p>
+            <a:pPr marL="0" indent="0">
               <a:lnSpc>
                 <a:spcPts val="1600"/>
               </a:lnSpc>
@@ -2874,16 +2623,16 @@
             <a:endParaRPr lang="en-US" sz="1100" dirty="0"/>
           </a:p>
           <a:p>
-            <a:pPr indent="0" marL="0">
-              <a:lnSpc>
-                <a:spcPts val="1600"/>
-              </a:lnSpc>
-              <a:buNone/>
-            </a:pPr>
-            <a:endParaRPr lang="en-US" sz="1100" dirty="0"/>
-          </a:p>
-          <a:p>
-            <a:pPr indent="0" marL="0">
+            <a:pPr marL="0" indent="0">
+              <a:lnSpc>
+                <a:spcPts val="1600"/>
+              </a:lnSpc>
+              <a:buNone/>
+            </a:pPr>
+            <a:endParaRPr lang="en-US" sz="1100" dirty="0"/>
+          </a:p>
+          <a:p>
+            <a:pPr marL="0" indent="0">
               <a:lnSpc>
                 <a:spcPts val="1600"/>
               </a:lnSpc>
@@ -2903,14 +2652,14 @@
       </p:sp>
       <p:pic>
         <p:nvPicPr>
-          <p:cNvPr id="8" name="Image 0" descr="C:\FUSION_HIGH_APP_1\FUSION_HIGH_APP_2.1\presentation_assets\screenshots\07_timetable_planner.png">    </p:cNvPr>
+          <p:cNvPr id="8" name="Image 0" descr="C:\FUSION_HIGH_APP_1\FUSION_HIGH_APP_2.1\presentation_assets\screenshots\07_timetable_planner.png"/>
           <p:cNvPicPr>
             <a:picLocks noChangeAspect="1"/>
           </p:cNvPicPr>
           <p:nvPr/>
         </p:nvPicPr>
         <p:blipFill>
-          <a:blip r:embed="rId1"/>
+          <a:blip r:embed="rId3"/>
           <a:stretch>
             <a:fillRect/>
           </a:stretch>
@@ -2941,6 +2690,7 @@
         <a:solidFill>
           <a:srgbClr val="0B0F19"/>
         </a:solidFill>
+        <a:effectLst/>
       </p:bgPr>
     </p:bg>
     <p:spTree>
@@ -2976,6 +2726,13 @@
           </a:solidFill>
           <a:ln/>
         </p:spPr>
+        <p:txBody>
+          <a:bodyPr/>
+          <a:lstStyle/>
+          <a:p>
+            <a:endParaRPr lang="en-US"/>
+          </a:p>
+        </p:txBody>
       </p:sp>
       <p:sp>
         <p:nvSpPr>
@@ -2998,7 +2755,7 @@
           <a:bodyPr wrap="square" rtlCol="0" anchor="ctr"/>
           <a:lstStyle/>
           <a:p>
-            <a:pPr indent="0" marL="0">
+            <a:pPr marL="0" indent="0">
               <a:buNone/>
             </a:pPr>
             <a:r>
@@ -3034,7 +2791,7 @@
           <a:bodyPr wrap="square" rtlCol="0" anchor="ctr"/>
           <a:lstStyle/>
           <a:p>
-            <a:pPr indent="0" marL="0">
+            <a:pPr marL="0" indent="0">
               <a:buNone/>
             </a:pPr>
             <a:r>
@@ -3075,6 +2832,13 @@
             <a:prstDash val="solid"/>
           </a:ln>
         </p:spPr>
+        <p:txBody>
+          <a:bodyPr/>
+          <a:lstStyle/>
+          <a:p>
+            <a:endParaRPr lang="en-US"/>
+          </a:p>
+        </p:txBody>
       </p:sp>
       <p:sp>
         <p:nvSpPr>
@@ -3097,7 +2861,7 @@
           <a:bodyPr wrap="square" rtlCol="0" anchor="ctr"/>
           <a:lstStyle/>
           <a:p>
-            <a:pPr indent="0" marL="0">
+            <a:pPr marL="0" indent="0">
               <a:buNone/>
             </a:pPr>
             <a:r>
@@ -3133,7 +2897,7 @@
           <a:bodyPr wrap="square" rtlCol="0" anchor="ctr"/>
           <a:lstStyle/>
           <a:p>
-            <a:pPr indent="0" marL="0">
+            <a:pPr marL="0" indent="0">
               <a:lnSpc>
                 <a:spcPts val="1600"/>
               </a:lnSpc>
@@ -3150,16 +2914,16 @@
             <a:endParaRPr lang="en-US" sz="1100" dirty="0"/>
           </a:p>
           <a:p>
-            <a:pPr indent="0" marL="0">
-              <a:lnSpc>
-                <a:spcPts val="1600"/>
-              </a:lnSpc>
-              <a:buNone/>
-            </a:pPr>
-            <a:endParaRPr lang="en-US" sz="1100" dirty="0"/>
-          </a:p>
-          <a:p>
-            <a:pPr indent="0" marL="0">
+            <a:pPr marL="0" indent="0">
+              <a:lnSpc>
+                <a:spcPts val="1600"/>
+              </a:lnSpc>
+              <a:buNone/>
+            </a:pPr>
+            <a:endParaRPr lang="en-US" sz="1100" dirty="0"/>
+          </a:p>
+          <a:p>
+            <a:pPr marL="0" indent="0">
               <a:lnSpc>
                 <a:spcPts val="1600"/>
               </a:lnSpc>
@@ -3176,16 +2940,16 @@
             <a:endParaRPr lang="en-US" sz="1100" dirty="0"/>
           </a:p>
           <a:p>
-            <a:pPr indent="0" marL="0">
-              <a:lnSpc>
-                <a:spcPts val="1600"/>
-              </a:lnSpc>
-              <a:buNone/>
-            </a:pPr>
-            <a:endParaRPr lang="en-US" sz="1100" dirty="0"/>
-          </a:p>
-          <a:p>
-            <a:pPr indent="0" marL="0">
+            <a:pPr marL="0" indent="0">
+              <a:lnSpc>
+                <a:spcPts val="1600"/>
+              </a:lnSpc>
+              <a:buNone/>
+            </a:pPr>
+            <a:endParaRPr lang="en-US" sz="1100" dirty="0"/>
+          </a:p>
+          <a:p>
+            <a:pPr marL="0" indent="0">
               <a:lnSpc>
                 <a:spcPts val="1600"/>
               </a:lnSpc>
@@ -3202,16 +2966,16 @@
             <a:endParaRPr lang="en-US" sz="1100" dirty="0"/>
           </a:p>
           <a:p>
-            <a:pPr indent="0" marL="0">
-              <a:lnSpc>
-                <a:spcPts val="1600"/>
-              </a:lnSpc>
-              <a:buNone/>
-            </a:pPr>
-            <a:endParaRPr lang="en-US" sz="1100" dirty="0"/>
-          </a:p>
-          <a:p>
-            <a:pPr indent="0" marL="0">
+            <a:pPr marL="0" indent="0">
+              <a:lnSpc>
+                <a:spcPts val="1600"/>
+              </a:lnSpc>
+              <a:buNone/>
+            </a:pPr>
+            <a:endParaRPr lang="en-US" sz="1100" dirty="0"/>
+          </a:p>
+          <a:p>
+            <a:pPr marL="0" indent="0">
               <a:lnSpc>
                 <a:spcPts val="1600"/>
               </a:lnSpc>
@@ -3231,14 +2995,14 @@
       </p:sp>
       <p:pic>
         <p:nvPicPr>
-          <p:cNvPr id="8" name="Image 0" descr="C:\FUSION_HIGH_APP_1\FUSION_HIGH_APP_2.1\presentation_assets\screenshots\08_fees_invoicing.png">    </p:cNvPr>
+          <p:cNvPr id="8" name="Image 0" descr="C:\FUSION_HIGH_APP_1\FUSION_HIGH_APP_2.1\presentation_assets\screenshots\08_fees_invoicing.png"/>
           <p:cNvPicPr>
             <a:picLocks noChangeAspect="1"/>
           </p:cNvPicPr>
           <p:nvPr/>
         </p:nvPicPr>
         <p:blipFill>
-          <a:blip r:embed="rId1"/>
+          <a:blip r:embed="rId3"/>
           <a:stretch>
             <a:fillRect/>
           </a:stretch>
@@ -3269,6 +3033,7 @@
         <a:solidFill>
           <a:srgbClr val="0B0F19"/>
         </a:solidFill>
+        <a:effectLst/>
       </p:bgPr>
     </p:bg>
     <p:spTree>
@@ -3304,6 +3069,13 @@
           </a:solidFill>
           <a:ln/>
         </p:spPr>
+        <p:txBody>
+          <a:bodyPr/>
+          <a:lstStyle/>
+          <a:p>
+            <a:endParaRPr lang="en-US"/>
+          </a:p>
+        </p:txBody>
       </p:sp>
       <p:sp>
         <p:nvSpPr>
@@ -3326,7 +3098,7 @@
           <a:bodyPr wrap="square" rtlCol="0" anchor="ctr"/>
           <a:lstStyle/>
           <a:p>
-            <a:pPr indent="0" marL="0">
+            <a:pPr marL="0" indent="0">
               <a:buNone/>
             </a:pPr>
             <a:r>
@@ -3362,7 +3134,7 @@
           <a:bodyPr wrap="square" rtlCol="0" anchor="ctr"/>
           <a:lstStyle/>
           <a:p>
-            <a:pPr indent="0" marL="0">
+            <a:pPr marL="0" indent="0">
               <a:buNone/>
             </a:pPr>
             <a:r>
@@ -3403,6 +3175,13 @@
             <a:prstDash val="solid"/>
           </a:ln>
         </p:spPr>
+        <p:txBody>
+          <a:bodyPr/>
+          <a:lstStyle/>
+          <a:p>
+            <a:endParaRPr lang="en-US"/>
+          </a:p>
+        </p:txBody>
       </p:sp>
       <p:sp>
         <p:nvSpPr>
@@ -3425,7 +3204,7 @@
           <a:bodyPr wrap="square" rtlCol="0" anchor="ctr"/>
           <a:lstStyle/>
           <a:p>
-            <a:pPr indent="0" marL="0">
+            <a:pPr marL="0" indent="0">
               <a:buNone/>
             </a:pPr>
             <a:r>
@@ -3461,7 +3240,7 @@
           <a:bodyPr wrap="square" rtlCol="0" anchor="ctr"/>
           <a:lstStyle/>
           <a:p>
-            <a:pPr indent="0" marL="0">
+            <a:pPr marL="0" indent="0">
               <a:lnSpc>
                 <a:spcPts val="1600"/>
               </a:lnSpc>
@@ -3478,16 +3257,16 @@
             <a:endParaRPr lang="en-US" sz="1100" dirty="0"/>
           </a:p>
           <a:p>
-            <a:pPr indent="0" marL="0">
-              <a:lnSpc>
-                <a:spcPts val="1600"/>
-              </a:lnSpc>
-              <a:buNone/>
-            </a:pPr>
-            <a:endParaRPr lang="en-US" sz="1100" dirty="0"/>
-          </a:p>
-          <a:p>
-            <a:pPr indent="0" marL="0">
+            <a:pPr marL="0" indent="0">
+              <a:lnSpc>
+                <a:spcPts val="1600"/>
+              </a:lnSpc>
+              <a:buNone/>
+            </a:pPr>
+            <a:endParaRPr lang="en-US" sz="1100" dirty="0"/>
+          </a:p>
+          <a:p>
+            <a:pPr marL="0" indent="0">
               <a:lnSpc>
                 <a:spcPts val="1600"/>
               </a:lnSpc>
@@ -3504,16 +3283,16 @@
             <a:endParaRPr lang="en-US" sz="1100" dirty="0"/>
           </a:p>
           <a:p>
-            <a:pPr indent="0" marL="0">
-              <a:lnSpc>
-                <a:spcPts val="1600"/>
-              </a:lnSpc>
-              <a:buNone/>
-            </a:pPr>
-            <a:endParaRPr lang="en-US" sz="1100" dirty="0"/>
-          </a:p>
-          <a:p>
-            <a:pPr indent="0" marL="0">
+            <a:pPr marL="0" indent="0">
+              <a:lnSpc>
+                <a:spcPts val="1600"/>
+              </a:lnSpc>
+              <a:buNone/>
+            </a:pPr>
+            <a:endParaRPr lang="en-US" sz="1100" dirty="0"/>
+          </a:p>
+          <a:p>
+            <a:pPr marL="0" indent="0">
               <a:lnSpc>
                 <a:spcPts val="1600"/>
               </a:lnSpc>
@@ -3530,16 +3309,16 @@
             <a:endParaRPr lang="en-US" sz="1100" dirty="0"/>
           </a:p>
           <a:p>
-            <a:pPr indent="0" marL="0">
-              <a:lnSpc>
-                <a:spcPts val="1600"/>
-              </a:lnSpc>
-              <a:buNone/>
-            </a:pPr>
-            <a:endParaRPr lang="en-US" sz="1100" dirty="0"/>
-          </a:p>
-          <a:p>
-            <a:pPr indent="0" marL="0">
+            <a:pPr marL="0" indent="0">
+              <a:lnSpc>
+                <a:spcPts val="1600"/>
+              </a:lnSpc>
+              <a:buNone/>
+            </a:pPr>
+            <a:endParaRPr lang="en-US" sz="1100" dirty="0"/>
+          </a:p>
+          <a:p>
+            <a:pPr marL="0" indent="0">
               <a:lnSpc>
                 <a:spcPts val="1600"/>
               </a:lnSpc>
@@ -3559,14 +3338,14 @@
       </p:sp>
       <p:pic>
         <p:nvPicPr>
-          <p:cNvPr id="8" name="Image 0" descr="C:\FUSION_HIGH_APP_1\FUSION_HIGH_APP_2.1\presentation_assets\screenshots\09_matric_projector.png">    </p:cNvPr>
+          <p:cNvPr id="8" name="Image 0" descr="C:\FUSION_HIGH_APP_1\FUSION_HIGH_APP_2.1\presentation_assets\screenshots\09_matric_projector.png"/>
           <p:cNvPicPr>
             <a:picLocks noChangeAspect="1"/>
           </p:cNvPicPr>
           <p:nvPr/>
         </p:nvPicPr>
         <p:blipFill>
-          <a:blip r:embed="rId1"/>
+          <a:blip r:embed="rId3"/>
           <a:stretch>
             <a:fillRect/>
           </a:stretch>
@@ -3597,6 +3376,7 @@
         <a:solidFill>
           <a:srgbClr val="0B0F19"/>
         </a:solidFill>
+        <a:effectLst/>
       </p:bgPr>
     </p:bg>
     <p:spTree>
@@ -3632,6 +3412,13 @@
           </a:solidFill>
           <a:ln/>
         </p:spPr>
+        <p:txBody>
+          <a:bodyPr/>
+          <a:lstStyle/>
+          <a:p>
+            <a:endParaRPr lang="en-US"/>
+          </a:p>
+        </p:txBody>
       </p:sp>
       <p:sp>
         <p:nvSpPr>
@@ -3654,7 +3441,7 @@
           <a:bodyPr wrap="square" rtlCol="0" anchor="ctr"/>
           <a:lstStyle/>
           <a:p>
-            <a:pPr indent="0" marL="0">
+            <a:pPr marL="0" indent="0">
               <a:buNone/>
             </a:pPr>
             <a:r>
@@ -3690,7 +3477,7 @@
           <a:bodyPr wrap="square" rtlCol="0" anchor="ctr"/>
           <a:lstStyle/>
           <a:p>
-            <a:pPr indent="0" marL="0">
+            <a:pPr marL="0" indent="0">
               <a:buNone/>
             </a:pPr>
             <a:r>
@@ -3731,6 +3518,13 @@
             <a:prstDash val="solid"/>
           </a:ln>
         </p:spPr>
+        <p:txBody>
+          <a:bodyPr/>
+          <a:lstStyle/>
+          <a:p>
+            <a:endParaRPr lang="en-US"/>
+          </a:p>
+        </p:txBody>
       </p:sp>
       <p:sp>
         <p:nvSpPr>
@@ -3753,7 +3547,7 @@
           <a:bodyPr wrap="square" rtlCol="0" anchor="ctr"/>
           <a:lstStyle/>
           <a:p>
-            <a:pPr indent="0" marL="0">
+            <a:pPr marL="0" indent="0">
               <a:buNone/>
             </a:pPr>
             <a:r>
@@ -3789,7 +3583,7 @@
           <a:bodyPr wrap="square" rtlCol="0" anchor="ctr"/>
           <a:lstStyle/>
           <a:p>
-            <a:pPr indent="0" marL="0">
+            <a:pPr marL="0" indent="0">
               <a:lnSpc>
                 <a:spcPts val="1600"/>
               </a:lnSpc>
@@ -3806,16 +3600,16 @@
             <a:endParaRPr lang="en-US" sz="1100" dirty="0"/>
           </a:p>
           <a:p>
-            <a:pPr indent="0" marL="0">
-              <a:lnSpc>
-                <a:spcPts val="1600"/>
-              </a:lnSpc>
-              <a:buNone/>
-            </a:pPr>
-            <a:endParaRPr lang="en-US" sz="1100" dirty="0"/>
-          </a:p>
-          <a:p>
-            <a:pPr indent="0" marL="0">
+            <a:pPr marL="0" indent="0">
+              <a:lnSpc>
+                <a:spcPts val="1600"/>
+              </a:lnSpc>
+              <a:buNone/>
+            </a:pPr>
+            <a:endParaRPr lang="en-US" sz="1100" dirty="0"/>
+          </a:p>
+          <a:p>
+            <a:pPr marL="0" indent="0">
               <a:lnSpc>
                 <a:spcPts val="1600"/>
               </a:lnSpc>
@@ -3832,16 +3626,16 @@
             <a:endParaRPr lang="en-US" sz="1100" dirty="0"/>
           </a:p>
           <a:p>
-            <a:pPr indent="0" marL="0">
-              <a:lnSpc>
-                <a:spcPts val="1600"/>
-              </a:lnSpc>
-              <a:buNone/>
-            </a:pPr>
-            <a:endParaRPr lang="en-US" sz="1100" dirty="0"/>
-          </a:p>
-          <a:p>
-            <a:pPr indent="0" marL="0">
+            <a:pPr marL="0" indent="0">
+              <a:lnSpc>
+                <a:spcPts val="1600"/>
+              </a:lnSpc>
+              <a:buNone/>
+            </a:pPr>
+            <a:endParaRPr lang="en-US" sz="1100" dirty="0"/>
+          </a:p>
+          <a:p>
+            <a:pPr marL="0" indent="0">
               <a:lnSpc>
                 <a:spcPts val="1600"/>
               </a:lnSpc>
@@ -3858,16 +3652,16 @@
             <a:endParaRPr lang="en-US" sz="1100" dirty="0"/>
           </a:p>
           <a:p>
-            <a:pPr indent="0" marL="0">
-              <a:lnSpc>
-                <a:spcPts val="1600"/>
-              </a:lnSpc>
-              <a:buNone/>
-            </a:pPr>
-            <a:endParaRPr lang="en-US" sz="1100" dirty="0"/>
-          </a:p>
-          <a:p>
-            <a:pPr indent="0" marL="0">
+            <a:pPr marL="0" indent="0">
+              <a:lnSpc>
+                <a:spcPts val="1600"/>
+              </a:lnSpc>
+              <a:buNone/>
+            </a:pPr>
+            <a:endParaRPr lang="en-US" sz="1100" dirty="0"/>
+          </a:p>
+          <a:p>
+            <a:pPr marL="0" indent="0">
               <a:lnSpc>
                 <a:spcPts val="1600"/>
               </a:lnSpc>
@@ -3887,14 +3681,14 @@
       </p:sp>
       <p:pic>
         <p:nvPicPr>
-          <p:cNvPr id="8" name="Image 0" descr="C:\FUSION_HIGH_APP_1\FUSION_HIGH_APP_2.1\presentation_assets\screenshots\10_leave_relief.png">    </p:cNvPr>
+          <p:cNvPr id="8" name="Image 0" descr="C:\FUSION_HIGH_APP_1\FUSION_HIGH_APP_2.1\presentation_assets\screenshots\10_leave_relief.png"/>
           <p:cNvPicPr>
             <a:picLocks noChangeAspect="1"/>
           </p:cNvPicPr>
           <p:nvPr/>
         </p:nvPicPr>
         <p:blipFill>
-          <a:blip r:embed="rId1"/>
+          <a:blip r:embed="rId3"/>
           <a:stretch>
             <a:fillRect/>
           </a:stretch>
@@ -3925,6 +3719,7 @@
         <a:solidFill>
           <a:srgbClr val="0B0F19"/>
         </a:solidFill>
+        <a:effectLst/>
       </p:bgPr>
     </p:bg>
     <p:spTree>
@@ -3960,6 +3755,13 @@
           </a:solidFill>
           <a:ln/>
         </p:spPr>
+        <p:txBody>
+          <a:bodyPr/>
+          <a:lstStyle/>
+          <a:p>
+            <a:endParaRPr lang="en-US"/>
+          </a:p>
+        </p:txBody>
       </p:sp>
       <p:sp>
         <p:nvSpPr>
@@ -3982,7 +3784,7 @@
           <a:bodyPr wrap="square" rtlCol="0" anchor="ctr"/>
           <a:lstStyle/>
           <a:p>
-            <a:pPr indent="0" marL="0">
+            <a:pPr marL="0" indent="0">
               <a:buNone/>
             </a:pPr>
             <a:r>
@@ -4018,7 +3820,7 @@
           <a:bodyPr wrap="square" rtlCol="0" anchor="ctr"/>
           <a:lstStyle/>
           <a:p>
-            <a:pPr indent="0" marL="0">
+            <a:pPr marL="0" indent="0">
               <a:buNone/>
             </a:pPr>
             <a:r>
@@ -4059,6 +3861,13 @@
             <a:prstDash val="solid"/>
           </a:ln>
         </p:spPr>
+        <p:txBody>
+          <a:bodyPr/>
+          <a:lstStyle/>
+          <a:p>
+            <a:endParaRPr lang="en-US"/>
+          </a:p>
+        </p:txBody>
       </p:sp>
       <p:sp>
         <p:nvSpPr>
@@ -4081,7 +3890,7 @@
           <a:bodyPr wrap="square" rtlCol="0" anchor="ctr"/>
           <a:lstStyle/>
           <a:p>
-            <a:pPr indent="0" marL="0">
+            <a:pPr marL="0" indent="0">
               <a:buNone/>
             </a:pPr>
             <a:r>
@@ -4117,7 +3926,7 @@
           <a:bodyPr wrap="square" rtlCol="0" anchor="ctr"/>
           <a:lstStyle/>
           <a:p>
-            <a:pPr indent="0" marL="0">
+            <a:pPr marL="0" indent="0">
               <a:lnSpc>
                 <a:spcPts val="1600"/>
               </a:lnSpc>
@@ -4134,16 +3943,16 @@
             <a:endParaRPr lang="en-US" sz="1100" dirty="0"/>
           </a:p>
           <a:p>
-            <a:pPr indent="0" marL="0">
-              <a:lnSpc>
-                <a:spcPts val="1600"/>
-              </a:lnSpc>
-              <a:buNone/>
-            </a:pPr>
-            <a:endParaRPr lang="en-US" sz="1100" dirty="0"/>
-          </a:p>
-          <a:p>
-            <a:pPr indent="0" marL="0">
+            <a:pPr marL="0" indent="0">
+              <a:lnSpc>
+                <a:spcPts val="1600"/>
+              </a:lnSpc>
+              <a:buNone/>
+            </a:pPr>
+            <a:endParaRPr lang="en-US" sz="1100" dirty="0"/>
+          </a:p>
+          <a:p>
+            <a:pPr marL="0" indent="0">
               <a:lnSpc>
                 <a:spcPts val="1600"/>
               </a:lnSpc>
@@ -4160,16 +3969,16 @@
             <a:endParaRPr lang="en-US" sz="1100" dirty="0"/>
           </a:p>
           <a:p>
-            <a:pPr indent="0" marL="0">
-              <a:lnSpc>
-                <a:spcPts val="1600"/>
-              </a:lnSpc>
-              <a:buNone/>
-            </a:pPr>
-            <a:endParaRPr lang="en-US" sz="1100" dirty="0"/>
-          </a:p>
-          <a:p>
-            <a:pPr indent="0" marL="0">
+            <a:pPr marL="0" indent="0">
+              <a:lnSpc>
+                <a:spcPts val="1600"/>
+              </a:lnSpc>
+              <a:buNone/>
+            </a:pPr>
+            <a:endParaRPr lang="en-US" sz="1100" dirty="0"/>
+          </a:p>
+          <a:p>
+            <a:pPr marL="0" indent="0">
               <a:lnSpc>
                 <a:spcPts val="1600"/>
               </a:lnSpc>
@@ -4186,16 +3995,16 @@
             <a:endParaRPr lang="en-US" sz="1100" dirty="0"/>
           </a:p>
           <a:p>
-            <a:pPr indent="0" marL="0">
-              <a:lnSpc>
-                <a:spcPts val="1600"/>
-              </a:lnSpc>
-              <a:buNone/>
-            </a:pPr>
-            <a:endParaRPr lang="en-US" sz="1100" dirty="0"/>
-          </a:p>
-          <a:p>
-            <a:pPr indent="0" marL="0">
+            <a:pPr marL="0" indent="0">
+              <a:lnSpc>
+                <a:spcPts val="1600"/>
+              </a:lnSpc>
+              <a:buNone/>
+            </a:pPr>
+            <a:endParaRPr lang="en-US" sz="1100" dirty="0"/>
+          </a:p>
+          <a:p>
+            <a:pPr marL="0" indent="0">
               <a:lnSpc>
                 <a:spcPts val="1600"/>
               </a:lnSpc>
@@ -4215,14 +4024,14 @@
       </p:sp>
       <p:pic>
         <p:nvPicPr>
-          <p:cNvPr id="8" name="Image 0" descr="C:\FUSION_HIGH_APP_1\FUSION_HIGH_APP_2.1\presentation_assets\screenshots\13_bursary_engine.png">    </p:cNvPr>
+          <p:cNvPr id="8" name="Image 0" descr="C:\FUSION_HIGH_APP_1\FUSION_HIGH_APP_2.1\presentation_assets\screenshots\13_bursary_engine.png"/>
           <p:cNvPicPr>
             <a:picLocks noChangeAspect="1"/>
           </p:cNvPicPr>
           <p:nvPr/>
         </p:nvPicPr>
         <p:blipFill>
-          <a:blip r:embed="rId1"/>
+          <a:blip r:embed="rId3"/>
           <a:stretch>
             <a:fillRect/>
           </a:stretch>
@@ -4253,6 +4062,7 @@
         <a:solidFill>
           <a:srgbClr val="0B0F19"/>
         </a:solidFill>
+        <a:effectLst/>
       </p:bgPr>
     </p:bg>
     <p:spTree>
@@ -4288,6 +4098,13 @@
           </a:solidFill>
           <a:ln/>
         </p:spPr>
+        <p:txBody>
+          <a:bodyPr/>
+          <a:lstStyle/>
+          <a:p>
+            <a:endParaRPr lang="en-US"/>
+          </a:p>
+        </p:txBody>
       </p:sp>
       <p:sp>
         <p:nvSpPr>
@@ -4310,7 +4127,7 @@
           <a:bodyPr wrap="square" rtlCol="0" anchor="ctr"/>
           <a:lstStyle/>
           <a:p>
-            <a:pPr indent="0" marL="0">
+            <a:pPr marL="0" indent="0">
               <a:buNone/>
             </a:pPr>
             <a:r>
@@ -4346,7 +4163,7 @@
           <a:bodyPr wrap="square" rtlCol="0" anchor="ctr"/>
           <a:lstStyle/>
           <a:p>
-            <a:pPr indent="0" marL="0">
+            <a:pPr marL="0" indent="0">
               <a:buNone/>
             </a:pPr>
             <a:r>
@@ -4387,6 +4204,13 @@
             <a:prstDash val="solid"/>
           </a:ln>
         </p:spPr>
+        <p:txBody>
+          <a:bodyPr/>
+          <a:lstStyle/>
+          <a:p>
+            <a:endParaRPr lang="en-US"/>
+          </a:p>
+        </p:txBody>
       </p:sp>
       <p:sp>
         <p:nvSpPr>
@@ -4409,7 +4233,7 @@
           <a:bodyPr wrap="square" rtlCol="0" anchor="ctr"/>
           <a:lstStyle/>
           <a:p>
-            <a:pPr indent="0" marL="0">
+            <a:pPr marL="0" indent="0">
               <a:buNone/>
             </a:pPr>
             <a:r>
@@ -4445,7 +4269,7 @@
           <a:bodyPr wrap="square" rtlCol="0" anchor="ctr"/>
           <a:lstStyle/>
           <a:p>
-            <a:pPr indent="0" marL="0">
+            <a:pPr marL="0" indent="0">
               <a:lnSpc>
                 <a:spcPts val="1600"/>
               </a:lnSpc>
@@ -4462,16 +4286,16 @@
             <a:endParaRPr lang="en-US" sz="1100" dirty="0"/>
           </a:p>
           <a:p>
-            <a:pPr indent="0" marL="0">
-              <a:lnSpc>
-                <a:spcPts val="1600"/>
-              </a:lnSpc>
-              <a:buNone/>
-            </a:pPr>
-            <a:endParaRPr lang="en-US" sz="1100" dirty="0"/>
-          </a:p>
-          <a:p>
-            <a:pPr indent="0" marL="0">
+            <a:pPr marL="0" indent="0">
+              <a:lnSpc>
+                <a:spcPts val="1600"/>
+              </a:lnSpc>
+              <a:buNone/>
+            </a:pPr>
+            <a:endParaRPr lang="en-US" sz="1100" dirty="0"/>
+          </a:p>
+          <a:p>
+            <a:pPr marL="0" indent="0">
               <a:lnSpc>
                 <a:spcPts val="1600"/>
               </a:lnSpc>
@@ -4488,16 +4312,16 @@
             <a:endParaRPr lang="en-US" sz="1100" dirty="0"/>
           </a:p>
           <a:p>
-            <a:pPr indent="0" marL="0">
-              <a:lnSpc>
-                <a:spcPts val="1600"/>
-              </a:lnSpc>
-              <a:buNone/>
-            </a:pPr>
-            <a:endParaRPr lang="en-US" sz="1100" dirty="0"/>
-          </a:p>
-          <a:p>
-            <a:pPr indent="0" marL="0">
+            <a:pPr marL="0" indent="0">
+              <a:lnSpc>
+                <a:spcPts val="1600"/>
+              </a:lnSpc>
+              <a:buNone/>
+            </a:pPr>
+            <a:endParaRPr lang="en-US" sz="1100" dirty="0"/>
+          </a:p>
+          <a:p>
+            <a:pPr marL="0" indent="0">
               <a:lnSpc>
                 <a:spcPts val="1600"/>
               </a:lnSpc>
@@ -4514,16 +4338,16 @@
             <a:endParaRPr lang="en-US" sz="1100" dirty="0"/>
           </a:p>
           <a:p>
-            <a:pPr indent="0" marL="0">
-              <a:lnSpc>
-                <a:spcPts val="1600"/>
-              </a:lnSpc>
-              <a:buNone/>
-            </a:pPr>
-            <a:endParaRPr lang="en-US" sz="1100" dirty="0"/>
-          </a:p>
-          <a:p>
-            <a:pPr indent="0" marL="0">
+            <a:pPr marL="0" indent="0">
+              <a:lnSpc>
+                <a:spcPts val="1600"/>
+              </a:lnSpc>
+              <a:buNone/>
+            </a:pPr>
+            <a:endParaRPr lang="en-US" sz="1100" dirty="0"/>
+          </a:p>
+          <a:p>
+            <a:pPr marL="0" indent="0">
               <a:lnSpc>
                 <a:spcPts val="1600"/>
               </a:lnSpc>
@@ -4543,14 +4367,14 @@
       </p:sp>
       <p:pic>
         <p:nvPicPr>
-          <p:cNvPr id="8" name="Image 0" descr="C:\FUSION_HIGH_APP_1\FUSION_HIGH_APP_2.1\presentation_assets\screenshots\14_ai_tutor.png">    </p:cNvPr>
+          <p:cNvPr id="8" name="Image 0" descr="C:\FUSION_HIGH_APP_1\FUSION_HIGH_APP_2.1\presentation_assets\screenshots\14_ai_tutor.png"/>
           <p:cNvPicPr>
             <a:picLocks noChangeAspect="1"/>
           </p:cNvPicPr>
           <p:nvPr/>
         </p:nvPicPr>
         <p:blipFill>
-          <a:blip r:embed="rId1"/>
+          <a:blip r:embed="rId3"/>
           <a:stretch>
             <a:fillRect/>
           </a:stretch>
@@ -4581,6 +4405,7 @@
         <a:solidFill>
           <a:srgbClr val="0B0F19"/>
         </a:solidFill>
+        <a:effectLst/>
       </p:bgPr>
     </p:bg>
     <p:spTree>
@@ -4616,6 +4441,13 @@
           </a:solidFill>
           <a:ln/>
         </p:spPr>
+        <p:txBody>
+          <a:bodyPr/>
+          <a:lstStyle/>
+          <a:p>
+            <a:endParaRPr lang="en-US"/>
+          </a:p>
+        </p:txBody>
       </p:sp>
       <p:sp>
         <p:nvSpPr>
@@ -4638,7 +4470,7 @@
           <a:bodyPr wrap="square" rtlCol="0" anchor="ctr"/>
           <a:lstStyle/>
           <a:p>
-            <a:pPr indent="0" marL="0">
+            <a:pPr marL="0" indent="0">
               <a:buNone/>
             </a:pPr>
             <a:r>
@@ -4674,7 +4506,7 @@
           <a:bodyPr wrap="square" rtlCol="0" anchor="ctr"/>
           <a:lstStyle/>
           <a:p>
-            <a:pPr indent="0" marL="0">
+            <a:pPr marL="0" indent="0">
               <a:buNone/>
             </a:pPr>
             <a:r>
@@ -4715,6 +4547,13 @@
             <a:prstDash val="solid"/>
           </a:ln>
         </p:spPr>
+        <p:txBody>
+          <a:bodyPr/>
+          <a:lstStyle/>
+          <a:p>
+            <a:endParaRPr lang="en-US"/>
+          </a:p>
+        </p:txBody>
       </p:sp>
       <p:sp>
         <p:nvSpPr>
@@ -4737,7 +4576,7 @@
           <a:bodyPr wrap="square" rtlCol="0" anchor="ctr"/>
           <a:lstStyle/>
           <a:p>
-            <a:pPr indent="0" marL="0">
+            <a:pPr marL="0" indent="0">
               <a:buNone/>
             </a:pPr>
             <a:r>
@@ -4773,7 +4612,7 @@
           <a:bodyPr wrap="square" rtlCol="0" anchor="ctr"/>
           <a:lstStyle/>
           <a:p>
-            <a:pPr indent="0" marL="0">
+            <a:pPr marL="0" indent="0">
               <a:lnSpc>
                 <a:spcPts val="1600"/>
               </a:lnSpc>
@@ -4790,16 +4629,16 @@
             <a:endParaRPr lang="en-US" sz="1100" dirty="0"/>
           </a:p>
           <a:p>
-            <a:pPr indent="0" marL="0">
-              <a:lnSpc>
-                <a:spcPts val="1600"/>
-              </a:lnSpc>
-              <a:buNone/>
-            </a:pPr>
-            <a:endParaRPr lang="en-US" sz="1100" dirty="0"/>
-          </a:p>
-          <a:p>
-            <a:pPr indent="0" marL="0">
+            <a:pPr marL="0" indent="0">
+              <a:lnSpc>
+                <a:spcPts val="1600"/>
+              </a:lnSpc>
+              <a:buNone/>
+            </a:pPr>
+            <a:endParaRPr lang="en-US" sz="1100" dirty="0"/>
+          </a:p>
+          <a:p>
+            <a:pPr marL="0" indent="0">
               <a:lnSpc>
                 <a:spcPts val="1600"/>
               </a:lnSpc>
@@ -4816,16 +4655,16 @@
             <a:endParaRPr lang="en-US" sz="1100" dirty="0"/>
           </a:p>
           <a:p>
-            <a:pPr indent="0" marL="0">
-              <a:lnSpc>
-                <a:spcPts val="1600"/>
-              </a:lnSpc>
-              <a:buNone/>
-            </a:pPr>
-            <a:endParaRPr lang="en-US" sz="1100" dirty="0"/>
-          </a:p>
-          <a:p>
-            <a:pPr indent="0" marL="0">
+            <a:pPr marL="0" indent="0">
+              <a:lnSpc>
+                <a:spcPts val="1600"/>
+              </a:lnSpc>
+              <a:buNone/>
+            </a:pPr>
+            <a:endParaRPr lang="en-US" sz="1100" dirty="0"/>
+          </a:p>
+          <a:p>
+            <a:pPr marL="0" indent="0">
               <a:lnSpc>
                 <a:spcPts val="1600"/>
               </a:lnSpc>
@@ -4842,16 +4681,16 @@
             <a:endParaRPr lang="en-US" sz="1100" dirty="0"/>
           </a:p>
           <a:p>
-            <a:pPr indent="0" marL="0">
-              <a:lnSpc>
-                <a:spcPts val="1600"/>
-              </a:lnSpc>
-              <a:buNone/>
-            </a:pPr>
-            <a:endParaRPr lang="en-US" sz="1100" dirty="0"/>
-          </a:p>
-          <a:p>
-            <a:pPr indent="0" marL="0">
+            <a:pPr marL="0" indent="0">
+              <a:lnSpc>
+                <a:spcPts val="1600"/>
+              </a:lnSpc>
+              <a:buNone/>
+            </a:pPr>
+            <a:endParaRPr lang="en-US" sz="1100" dirty="0"/>
+          </a:p>
+          <a:p>
+            <a:pPr marL="0" indent="0">
               <a:lnSpc>
                 <a:spcPts val="1600"/>
               </a:lnSpc>
@@ -4871,14 +4710,14 @@
       </p:sp>
       <p:pic>
         <p:nvPicPr>
-          <p:cNvPr id="8" name="Image 0" descr="C:\FUSION_HIGH_APP_1\FUSION_HIGH_APP_2.1\presentation_assets\screenshots\15_textbook_inventory.png">    </p:cNvPr>
+          <p:cNvPr id="8" name="Image 0" descr="C:\FUSION_HIGH_APP_1\FUSION_HIGH_APP_2.1\presentation_assets\screenshots\15_textbook_inventory.png"/>
           <p:cNvPicPr>
             <a:picLocks noChangeAspect="1"/>
           </p:cNvPicPr>
           <p:nvPr/>
         </p:nvPicPr>
         <p:blipFill>
-          <a:blip r:embed="rId1"/>
+          <a:blip r:embed="rId3"/>
           <a:stretch>
             <a:fillRect/>
           </a:stretch>
@@ -4909,6 +4748,7 @@
         <a:solidFill>
           <a:srgbClr val="0B0F19"/>
         </a:solidFill>
+        <a:effectLst/>
       </p:bgPr>
     </p:bg>
     <p:spTree>
@@ -4946,7 +4786,7 @@
           <a:bodyPr wrap="square" rtlCol="0" anchor="ctr"/>
           <a:lstStyle/>
           <a:p>
-            <a:pPr indent="0" marL="0">
+            <a:pPr marL="0" indent="0">
               <a:buNone/>
             </a:pPr>
             <a:r>
@@ -4982,7 +4822,7 @@
           <a:bodyPr wrap="square" rtlCol="0" anchor="ctr"/>
           <a:lstStyle/>
           <a:p>
-            <a:pPr indent="0" marL="0">
+            <a:pPr marL="0" indent="0">
               <a:buNone/>
             </a:pPr>
             <a:r>
@@ -5023,6 +4863,13 @@
             <a:prstDash val="solid"/>
           </a:ln>
         </p:spPr>
+        <p:txBody>
+          <a:bodyPr/>
+          <a:lstStyle/>
+          <a:p>
+            <a:endParaRPr lang="en-US"/>
+          </a:p>
+        </p:txBody>
       </p:sp>
       <p:sp>
         <p:nvSpPr>
@@ -5045,7 +4892,7 @@
           <a:bodyPr wrap="square" rtlCol="0" anchor="ctr"/>
           <a:lstStyle/>
           <a:p>
-            <a:pPr indent="0" marL="0">
+            <a:pPr marL="0" indent="0">
               <a:buNone/>
             </a:pPr>
             <a:r>
@@ -5081,7 +4928,7 @@
           <a:bodyPr wrap="square" rtlCol="0" anchor="ctr"/>
           <a:lstStyle/>
           <a:p>
-            <a:pPr indent="0" marL="0">
+            <a:pPr marL="0" indent="0">
               <a:lnSpc>
                 <a:spcPts val="1800"/>
               </a:lnSpc>
@@ -5125,6 +4972,13 @@
             <a:prstDash val="solid"/>
           </a:ln>
         </p:spPr>
+        <p:txBody>
+          <a:bodyPr/>
+          <a:lstStyle/>
+          <a:p>
+            <a:endParaRPr lang="en-US"/>
+          </a:p>
+        </p:txBody>
       </p:sp>
       <p:sp>
         <p:nvSpPr>
@@ -5147,7 +5001,7 @@
           <a:bodyPr wrap="square" rtlCol="0" anchor="ctr"/>
           <a:lstStyle/>
           <a:p>
-            <a:pPr indent="0" marL="0">
+            <a:pPr marL="0" indent="0">
               <a:buNone/>
             </a:pPr>
             <a:r>
@@ -5183,7 +5037,7 @@
           <a:bodyPr wrap="square" rtlCol="0" anchor="ctr"/>
           <a:lstStyle/>
           <a:p>
-            <a:pPr indent="0" marL="0">
+            <a:pPr marL="0" indent="0">
               <a:lnSpc>
                 <a:spcPts val="1800"/>
               </a:lnSpc>
@@ -5227,6 +5081,13 @@
             <a:prstDash val="solid"/>
           </a:ln>
         </p:spPr>
+        <p:txBody>
+          <a:bodyPr/>
+          <a:lstStyle/>
+          <a:p>
+            <a:endParaRPr lang="en-US"/>
+          </a:p>
+        </p:txBody>
       </p:sp>
       <p:sp>
         <p:nvSpPr>
@@ -5249,7 +5110,7 @@
           <a:bodyPr wrap="square" rtlCol="0" anchor="ctr"/>
           <a:lstStyle/>
           <a:p>
-            <a:pPr indent="0" marL="0">
+            <a:pPr marL="0" indent="0">
               <a:buNone/>
             </a:pPr>
             <a:r>
@@ -5285,7 +5146,7 @@
           <a:bodyPr wrap="square" rtlCol="0" anchor="ctr"/>
           <a:lstStyle/>
           <a:p>
-            <a:pPr indent="0" marL="0">
+            <a:pPr marL="0" indent="0">
               <a:lnSpc>
                 <a:spcPts val="1800"/>
               </a:lnSpc>
@@ -5329,6 +5190,13 @@
             <a:prstDash val="solid"/>
           </a:ln>
         </p:spPr>
+        <p:txBody>
+          <a:bodyPr/>
+          <a:lstStyle/>
+          <a:p>
+            <a:endParaRPr lang="en-US"/>
+          </a:p>
+        </p:txBody>
       </p:sp>
       <p:sp>
         <p:nvSpPr>
@@ -5351,7 +5219,7 @@
           <a:bodyPr wrap="square" rtlCol="0" anchor="ctr"/>
           <a:lstStyle/>
           <a:p>
-            <a:pPr indent="0" marL="0">
+            <a:pPr marL="0" indent="0">
               <a:buNone/>
             </a:pPr>
             <a:r>
@@ -5387,7 +5255,7 @@
           <a:bodyPr wrap="square" rtlCol="0" anchor="ctr"/>
           <a:lstStyle/>
           <a:p>
-            <a:pPr indent="0" marL="0">
+            <a:pPr marL="0" indent="0">
               <a:lnSpc>
                 <a:spcPts val="1800"/>
               </a:lnSpc>
@@ -5421,6 +5289,7 @@
         <a:solidFill>
           <a:srgbClr val="0B0F19"/>
         </a:solidFill>
+        <a:effectLst/>
       </p:bgPr>
     </p:bg>
     <p:spTree>
@@ -5456,6 +5325,13 @@
           </a:solidFill>
           <a:ln/>
         </p:spPr>
+        <p:txBody>
+          <a:bodyPr/>
+          <a:lstStyle/>
+          <a:p>
+            <a:endParaRPr lang="en-US"/>
+          </a:p>
+        </p:txBody>
       </p:sp>
       <p:sp>
         <p:nvSpPr>
@@ -5478,7 +5354,7 @@
           <a:bodyPr wrap="square" rtlCol="0" anchor="ctr"/>
           <a:lstStyle/>
           <a:p>
-            <a:pPr indent="0" marL="0">
+            <a:pPr marL="0" indent="0">
               <a:buNone/>
             </a:pPr>
             <a:r>
@@ -5514,7 +5390,7 @@
           <a:bodyPr wrap="square" rtlCol="0" anchor="ctr"/>
           <a:lstStyle/>
           <a:p>
-            <a:pPr indent="0" marL="0">
+            <a:pPr marL="0" indent="0">
               <a:buNone/>
             </a:pPr>
             <a:r>
@@ -5550,7 +5426,7 @@
           <a:bodyPr wrap="square" rtlCol="0" anchor="ctr"/>
           <a:lstStyle/>
           <a:p>
-            <a:pPr indent="0" marL="0">
+            <a:pPr marL="0" indent="0">
               <a:lnSpc>
                 <a:spcPts val="2200"/>
               </a:lnSpc>
@@ -5564,12 +5440,6 @@
               </a:rPr>
               <a:t>✓ 12 Active Schools Configured: </a:t>
             </a:r>
-            <a:pPr indent="0" marL="0">
-              <a:lnSpc>
-                <a:spcPts val="2200"/>
-              </a:lnSpc>
-              <a:buNone/>
-            </a:pPr>
             <a:r>
               <a:rPr lang="en-US" sz="1300" dirty="0">
                 <a:solidFill>
@@ -5579,12 +5449,6 @@
               <a:t>Complete circuit and provincial profiles.
 </a:t>
             </a:r>
-            <a:pPr indent="0" marL="0">
-              <a:lnSpc>
-                <a:spcPts val="2200"/>
-              </a:lnSpc>
-              <a:buNone/>
-            </a:pPr>
             <a:r>
               <a:rPr lang="en-US" sz="1300" b="1" dirty="0">
                 <a:solidFill>
@@ -5593,12 +5457,6 @@
               </a:rPr>
               <a:t>✓ Multi-Tenant Administration: </a:t>
             </a:r>
-            <a:pPr indent="0" marL="0">
-              <a:lnSpc>
-                <a:spcPts val="2200"/>
-              </a:lnSpc>
-              <a:buNone/>
-            </a:pPr>
             <a:r>
               <a:rPr lang="en-US" sz="1300" dirty="0">
                 <a:solidFill>
@@ -5608,12 +5466,6 @@
               <a:t>Main SuperAdmin governance with isolated SubAdmins.
 </a:t>
             </a:r>
-            <a:pPr indent="0" marL="0">
-              <a:lnSpc>
-                <a:spcPts val="2200"/>
-              </a:lnSpc>
-              <a:buNone/>
-            </a:pPr>
             <a:r>
               <a:rPr lang="en-US" sz="1300" b="1" dirty="0">
                 <a:solidFill>
@@ -5622,12 +5474,6 @@
               </a:rPr>
               <a:t>✓ Zero Mock / Dummy Data: </a:t>
             </a:r>
-            <a:pPr indent="0" marL="0">
-              <a:lnSpc>
-                <a:spcPts val="2200"/>
-              </a:lnSpc>
-              <a:buNone/>
-            </a:pPr>
             <a:r>
               <a:rPr lang="en-US" sz="1300" dirty="0">
                 <a:solidFill>
@@ -5637,12 +5483,6 @@
               <a:t>All statistics, marks, and rosters query real database tables.
 </a:t>
             </a:r>
-            <a:pPr indent="0" marL="0">
-              <a:lnSpc>
-                <a:spcPts val="2200"/>
-              </a:lnSpc>
-              <a:buNone/>
-            </a:pPr>
             <a:r>
               <a:rPr lang="en-US" sz="1300" b="1" dirty="0">
                 <a:solidFill>
@@ -5651,12 +5491,6 @@
               </a:rPr>
               <a:t>✓ Automated Email Services: </a:t>
             </a:r>
-            <a:pPr indent="0" marL="0">
-              <a:lnSpc>
-                <a:spcPts val="2200"/>
-              </a:lnSpc>
-              <a:buNone/>
-            </a:pPr>
             <a:r>
               <a:rPr lang="en-US" sz="1300" dirty="0">
                 <a:solidFill>
@@ -5685,6 +5519,7 @@
         <a:solidFill>
           <a:srgbClr val="0B0F19"/>
         </a:solidFill>
+        <a:effectLst/>
       </p:bgPr>
     </p:bg>
     <p:spTree>
@@ -5709,8 +5544,8 @@
         </p:nvSpPr>
         <p:spPr>
           <a:xfrm>
-            <a:off x="731520" y="548640"/>
-            <a:ext cx="10698480" cy="548640"/>
+            <a:off x="15240" y="533401"/>
+            <a:ext cx="9075420" cy="548640"/>
           </a:xfrm>
           <a:prstGeom prst="rect">
             <a:avLst/>
@@ -5722,7 +5557,7 @@
           <a:bodyPr wrap="square" rtlCol="0" anchor="ctr"/>
           <a:lstStyle/>
           <a:p>
-            <a:pPr indent="0" marL="0">
+            <a:pPr marL="0" indent="0" algn="ctr">
               <a:buNone/>
             </a:pPr>
             <a:r>
@@ -5745,8 +5580,8 @@
         </p:nvSpPr>
         <p:spPr>
           <a:xfrm>
-            <a:off x="731520" y="1097280"/>
-            <a:ext cx="10698480" cy="457200"/>
+            <a:off x="0" y="1097280"/>
+            <a:ext cx="9144000" cy="457200"/>
           </a:xfrm>
           <a:prstGeom prst="rect">
             <a:avLst/>
@@ -5758,7 +5593,7 @@
           <a:bodyPr wrap="square" rtlCol="0" anchor="ctr"/>
           <a:lstStyle/>
           <a:p>
-            <a:pPr indent="0" marL="0">
+            <a:pPr marL="0" indent="0" algn="ctr">
               <a:buNone/>
             </a:pPr>
             <a:r>
@@ -5781,8 +5616,8 @@
         </p:nvSpPr>
         <p:spPr>
           <a:xfrm>
-            <a:off x="731520" y="1828800"/>
-            <a:ext cx="5120640" cy="2011680"/>
+            <a:off x="0" y="1565910"/>
+            <a:ext cx="4404360" cy="1771650"/>
           </a:xfrm>
           <a:prstGeom prst="roundRect">
             <a:avLst>
@@ -5799,6 +5634,13 @@
             <a:prstDash val="solid"/>
           </a:ln>
         </p:spPr>
+        <p:txBody>
+          <a:bodyPr/>
+          <a:lstStyle/>
+          <a:p>
+            <a:endParaRPr lang="en-US"/>
+          </a:p>
+        </p:txBody>
       </p:sp>
       <p:sp>
         <p:nvSpPr>
@@ -5808,8 +5650,8 @@
         </p:nvSpPr>
         <p:spPr>
           <a:xfrm>
-            <a:off x="1005840" y="2103120"/>
-            <a:ext cx="4572000" cy="365760"/>
+            <a:off x="7620" y="1611630"/>
+            <a:ext cx="4351020" cy="598170"/>
           </a:xfrm>
           <a:prstGeom prst="rect">
             <a:avLst/>
@@ -5821,7 +5663,7 @@
           <a:bodyPr wrap="square" rtlCol="0" anchor="ctr"/>
           <a:lstStyle/>
           <a:p>
-            <a:pPr indent="0" marL="0">
+            <a:pPr marL="0" indent="0" algn="ctr">
               <a:buNone/>
             </a:pPr>
             <a:r>
@@ -5844,8 +5686,8 @@
         </p:nvSpPr>
         <p:spPr>
           <a:xfrm>
-            <a:off x="1005840" y="2560320"/>
-            <a:ext cx="4572000" cy="1097280"/>
+            <a:off x="0" y="2209800"/>
+            <a:ext cx="4351020" cy="998220"/>
           </a:xfrm>
           <a:prstGeom prst="rect">
             <a:avLst/>
@@ -5857,7 +5699,7 @@
           <a:bodyPr wrap="square" rtlCol="0" anchor="ctr"/>
           <a:lstStyle/>
           <a:p>
-            <a:pPr indent="0" marL="0">
+            <a:pPr marL="0" indent="0" algn="ctr">
               <a:lnSpc>
                 <a:spcPts val="1600"/>
               </a:lnSpc>
@@ -5883,8 +5725,8 @@
         </p:nvSpPr>
         <p:spPr>
           <a:xfrm>
-            <a:off x="6126480" y="1828800"/>
-            <a:ext cx="5120640" cy="2011680"/>
+            <a:off x="4419600" y="1577341"/>
+            <a:ext cx="4724400" cy="1771650"/>
           </a:xfrm>
           <a:prstGeom prst="roundRect">
             <a:avLst>
@@ -5901,6 +5743,13 @@
             <a:prstDash val="solid"/>
           </a:ln>
         </p:spPr>
+        <p:txBody>
+          <a:bodyPr/>
+          <a:lstStyle/>
+          <a:p>
+            <a:endParaRPr lang="en-US"/>
+          </a:p>
+        </p:txBody>
       </p:sp>
       <p:sp>
         <p:nvSpPr>
@@ -5910,8 +5759,8 @@
         </p:nvSpPr>
         <p:spPr>
           <a:xfrm>
-            <a:off x="6400800" y="2103120"/>
-            <a:ext cx="4572000" cy="365760"/>
+            <a:off x="4419600" y="1645920"/>
+            <a:ext cx="5120640" cy="563880"/>
           </a:xfrm>
           <a:prstGeom prst="rect">
             <a:avLst/>
@@ -5923,7 +5772,7 @@
           <a:bodyPr wrap="square" rtlCol="0" anchor="ctr"/>
           <a:lstStyle/>
           <a:p>
-            <a:pPr indent="0" marL="0">
+            <a:pPr marL="0" indent="0" algn="ctr">
               <a:buNone/>
             </a:pPr>
             <a:r>
@@ -5946,8 +5795,8 @@
         </p:nvSpPr>
         <p:spPr>
           <a:xfrm>
-            <a:off x="6400800" y="2560320"/>
-            <a:ext cx="4572000" cy="1097280"/>
+            <a:off x="4419600" y="2209800"/>
+            <a:ext cx="4724400" cy="998220"/>
           </a:xfrm>
           <a:prstGeom prst="rect">
             <a:avLst/>
@@ -5959,7 +5808,7 @@
           <a:bodyPr wrap="square" rtlCol="0" anchor="ctr"/>
           <a:lstStyle/>
           <a:p>
-            <a:pPr indent="0" marL="0">
+            <a:pPr marL="0" indent="0" algn="ctr">
               <a:lnSpc>
                 <a:spcPts val="1600"/>
               </a:lnSpc>
@@ -5985,8 +5834,8 @@
         </p:nvSpPr>
         <p:spPr>
           <a:xfrm>
-            <a:off x="731520" y="4114800"/>
-            <a:ext cx="5120640" cy="2011680"/>
+            <a:off x="7620" y="3371850"/>
+            <a:ext cx="4396740" cy="1718310"/>
           </a:xfrm>
           <a:prstGeom prst="roundRect">
             <a:avLst>
@@ -6003,6 +5852,13 @@
             <a:prstDash val="solid"/>
           </a:ln>
         </p:spPr>
+        <p:txBody>
+          <a:bodyPr/>
+          <a:lstStyle/>
+          <a:p>
+            <a:endParaRPr lang="en-US"/>
+          </a:p>
+        </p:txBody>
       </p:sp>
       <p:sp>
         <p:nvSpPr>
@@ -6012,8 +5868,8 @@
         </p:nvSpPr>
         <p:spPr>
           <a:xfrm>
-            <a:off x="1005840" y="4389120"/>
-            <a:ext cx="4572000" cy="365760"/>
+            <a:off x="-53340" y="3531870"/>
+            <a:ext cx="4465320" cy="514350"/>
           </a:xfrm>
           <a:prstGeom prst="rect">
             <a:avLst/>
@@ -6025,7 +5881,7 @@
           <a:bodyPr wrap="square" rtlCol="0" anchor="ctr"/>
           <a:lstStyle/>
           <a:p>
-            <a:pPr indent="0" marL="0">
+            <a:pPr marL="0" indent="0" algn="ctr">
               <a:buNone/>
             </a:pPr>
             <a:r>
@@ -6048,8 +5904,8 @@
         </p:nvSpPr>
         <p:spPr>
           <a:xfrm>
-            <a:off x="1005840" y="4846320"/>
-            <a:ext cx="4572000" cy="1097280"/>
+            <a:off x="22860" y="4046220"/>
+            <a:ext cx="4389120" cy="998220"/>
           </a:xfrm>
           <a:prstGeom prst="rect">
             <a:avLst/>
@@ -6061,7 +5917,7 @@
           <a:bodyPr wrap="square" rtlCol="0" anchor="ctr"/>
           <a:lstStyle/>
           <a:p>
-            <a:pPr indent="0" marL="0">
+            <a:pPr marL="0" indent="0" algn="ctr">
               <a:lnSpc>
                 <a:spcPts val="1600"/>
               </a:lnSpc>
@@ -6087,8 +5943,8 @@
         </p:nvSpPr>
         <p:spPr>
           <a:xfrm>
-            <a:off x="6126480" y="4114800"/>
-            <a:ext cx="5120640" cy="2011680"/>
+            <a:off x="4419600" y="3348991"/>
+            <a:ext cx="4724400" cy="1741169"/>
           </a:xfrm>
           <a:prstGeom prst="roundRect">
             <a:avLst>
@@ -6105,6 +5961,13 @@
             <a:prstDash val="solid"/>
           </a:ln>
         </p:spPr>
+        <p:txBody>
+          <a:bodyPr/>
+          <a:lstStyle/>
+          <a:p>
+            <a:endParaRPr lang="en-US"/>
+          </a:p>
+        </p:txBody>
       </p:sp>
       <p:sp>
         <p:nvSpPr>
@@ -6114,8 +5977,8 @@
         </p:nvSpPr>
         <p:spPr>
           <a:xfrm>
-            <a:off x="6400800" y="4389120"/>
-            <a:ext cx="4572000" cy="365760"/>
+            <a:off x="4427220" y="3531870"/>
+            <a:ext cx="4716780" cy="514350"/>
           </a:xfrm>
           <a:prstGeom prst="rect">
             <a:avLst/>
@@ -6127,7 +5990,7 @@
           <a:bodyPr wrap="square" rtlCol="0" anchor="ctr"/>
           <a:lstStyle/>
           <a:p>
-            <a:pPr indent="0" marL="0">
+            <a:pPr marL="0" indent="0" algn="ctr">
               <a:buNone/>
             </a:pPr>
             <a:r>
@@ -6150,8 +6013,8 @@
         </p:nvSpPr>
         <p:spPr>
           <a:xfrm>
-            <a:off x="6400800" y="4846320"/>
-            <a:ext cx="4572000" cy="1097280"/>
+            <a:off x="4404360" y="4046220"/>
+            <a:ext cx="4716780" cy="1043940"/>
           </a:xfrm>
           <a:prstGeom prst="rect">
             <a:avLst/>
@@ -6163,7 +6026,7 @@
           <a:bodyPr wrap="square" rtlCol="0" anchor="ctr"/>
           <a:lstStyle/>
           <a:p>
-            <a:pPr indent="0" marL="0">
+            <a:pPr marL="0" indent="0" algn="ctr">
               <a:lnSpc>
                 <a:spcPts val="1600"/>
               </a:lnSpc>
@@ -6197,6 +6060,7 @@
         <a:solidFill>
           <a:srgbClr val="0B0F19"/>
         </a:solidFill>
+        <a:effectLst/>
       </p:bgPr>
     </p:bg>
     <p:spTree>
@@ -6221,8 +6085,8 @@
         </p:nvSpPr>
         <p:spPr>
           <a:xfrm>
-            <a:off x="731520" y="457200"/>
-            <a:ext cx="10698480" cy="73152"/>
+            <a:off x="0" y="422148"/>
+            <a:ext cx="9144000" cy="217932"/>
           </a:xfrm>
           <a:prstGeom prst="rect">
             <a:avLst/>
@@ -6232,6 +6096,13 @@
           </a:solidFill>
           <a:ln/>
         </p:spPr>
+        <p:txBody>
+          <a:bodyPr/>
+          <a:lstStyle/>
+          <a:p>
+            <a:endParaRPr lang="en-US"/>
+          </a:p>
+        </p:txBody>
       </p:sp>
       <p:sp>
         <p:nvSpPr>
@@ -6241,8 +6112,8 @@
         </p:nvSpPr>
         <p:spPr>
           <a:xfrm>
-            <a:off x="731520" y="640080"/>
-            <a:ext cx="10698480" cy="457200"/>
+            <a:off x="53340" y="640080"/>
+            <a:ext cx="9090660" cy="457200"/>
           </a:xfrm>
           <a:prstGeom prst="rect">
             <a:avLst/>
@@ -6254,7 +6125,7 @@
           <a:bodyPr wrap="square" rtlCol="0" anchor="ctr"/>
           <a:lstStyle/>
           <a:p>
-            <a:pPr indent="0" marL="0">
+            <a:pPr marL="0" indent="0">
               <a:buNone/>
             </a:pPr>
             <a:r>
@@ -6277,8 +6148,8 @@
         </p:nvSpPr>
         <p:spPr>
           <a:xfrm>
-            <a:off x="731520" y="1097280"/>
-            <a:ext cx="10698480" cy="365760"/>
+            <a:off x="0" y="1097280"/>
+            <a:ext cx="9144000" cy="365760"/>
           </a:xfrm>
           <a:prstGeom prst="rect">
             <a:avLst/>
@@ -6290,7 +6161,7 @@
           <a:bodyPr wrap="square" rtlCol="0" anchor="ctr"/>
           <a:lstStyle/>
           <a:p>
-            <a:pPr indent="0" marL="0">
+            <a:pPr marL="0" indent="0">
               <a:buNone/>
             </a:pPr>
             <a:r>
@@ -6313,8 +6184,8 @@
         </p:nvSpPr>
         <p:spPr>
           <a:xfrm>
-            <a:off x="731520" y="1645920"/>
-            <a:ext cx="4389120" cy="4389120"/>
+            <a:off x="53340" y="1584960"/>
+            <a:ext cx="4130040" cy="3474720"/>
           </a:xfrm>
           <a:prstGeom prst="roundRect">
             <a:avLst>
@@ -6331,6 +6202,13 @@
             <a:prstDash val="solid"/>
           </a:ln>
         </p:spPr>
+        <p:txBody>
+          <a:bodyPr/>
+          <a:lstStyle/>
+          <a:p>
+            <a:endParaRPr lang="en-US"/>
+          </a:p>
+        </p:txBody>
       </p:sp>
       <p:sp>
         <p:nvSpPr>
@@ -6353,7 +6231,7 @@
           <a:bodyPr wrap="square" rtlCol="0" anchor="ctr"/>
           <a:lstStyle/>
           <a:p>
-            <a:pPr indent="0" marL="0">
+            <a:pPr marL="0" indent="0">
               <a:buNone/>
             </a:pPr>
             <a:r>
@@ -6376,8 +6254,8 @@
         </p:nvSpPr>
         <p:spPr>
           <a:xfrm>
-            <a:off x="1005840" y="2286000"/>
-            <a:ext cx="3840480" cy="3474720"/>
+            <a:off x="137160" y="2286000"/>
+            <a:ext cx="4221480" cy="2636520"/>
           </a:xfrm>
           <a:prstGeom prst="rect">
             <a:avLst/>
@@ -6389,7 +6267,7 @@
           <a:bodyPr wrap="square" rtlCol="0" anchor="ctr"/>
           <a:lstStyle/>
           <a:p>
-            <a:pPr indent="0" marL="0">
+            <a:pPr marL="0" indent="0">
               <a:lnSpc>
                 <a:spcPts val="1600"/>
               </a:lnSpc>
@@ -6406,16 +6284,16 @@
             <a:endParaRPr lang="en-US" sz="1100" dirty="0"/>
           </a:p>
           <a:p>
-            <a:pPr indent="0" marL="0">
-              <a:lnSpc>
-                <a:spcPts val="1600"/>
-              </a:lnSpc>
-              <a:buNone/>
-            </a:pPr>
-            <a:endParaRPr lang="en-US" sz="1100" dirty="0"/>
-          </a:p>
-          <a:p>
-            <a:pPr indent="0" marL="0">
+            <a:pPr marL="0" indent="0">
+              <a:lnSpc>
+                <a:spcPts val="1600"/>
+              </a:lnSpc>
+              <a:buNone/>
+            </a:pPr>
+            <a:endParaRPr lang="en-US" sz="1100" dirty="0"/>
+          </a:p>
+          <a:p>
+            <a:pPr marL="0" indent="0">
               <a:lnSpc>
                 <a:spcPts val="1600"/>
               </a:lnSpc>
@@ -6432,16 +6310,16 @@
             <a:endParaRPr lang="en-US" sz="1100" dirty="0"/>
           </a:p>
           <a:p>
-            <a:pPr indent="0" marL="0">
-              <a:lnSpc>
-                <a:spcPts val="1600"/>
-              </a:lnSpc>
-              <a:buNone/>
-            </a:pPr>
-            <a:endParaRPr lang="en-US" sz="1100" dirty="0"/>
-          </a:p>
-          <a:p>
-            <a:pPr indent="0" marL="0">
+            <a:pPr marL="0" indent="0">
+              <a:lnSpc>
+                <a:spcPts val="1600"/>
+              </a:lnSpc>
+              <a:buNone/>
+            </a:pPr>
+            <a:endParaRPr lang="en-US" sz="1100" dirty="0"/>
+          </a:p>
+          <a:p>
+            <a:pPr marL="0" indent="0">
               <a:lnSpc>
                 <a:spcPts val="1600"/>
               </a:lnSpc>
@@ -6458,16 +6336,16 @@
             <a:endParaRPr lang="en-US" sz="1100" dirty="0"/>
           </a:p>
           <a:p>
-            <a:pPr indent="0" marL="0">
-              <a:lnSpc>
-                <a:spcPts val="1600"/>
-              </a:lnSpc>
-              <a:buNone/>
-            </a:pPr>
-            <a:endParaRPr lang="en-US" sz="1100" dirty="0"/>
-          </a:p>
-          <a:p>
-            <a:pPr indent="0" marL="0">
+            <a:pPr marL="0" indent="0">
+              <a:lnSpc>
+                <a:spcPts val="1600"/>
+              </a:lnSpc>
+              <a:buNone/>
+            </a:pPr>
+            <a:endParaRPr lang="en-US" sz="1100" dirty="0"/>
+          </a:p>
+          <a:p>
+            <a:pPr marL="0" indent="0">
               <a:lnSpc>
                 <a:spcPts val="1600"/>
               </a:lnSpc>
@@ -6487,22 +6365,22 @@
       </p:sp>
       <p:pic>
         <p:nvPicPr>
-          <p:cNvPr id="8" name="Image 0" descr="C:\FUSION_HIGH_APP_1\FUSION_HIGH_APP_2.1\presentation_assets\screenshots\01_landing_page.png">    </p:cNvPr>
+          <p:cNvPr id="8" name="Image 0" descr="C:\FUSION_HIGH_APP_1\FUSION_HIGH_APP_2.1\presentation_assets\screenshots\01_landing_page.png"/>
           <p:cNvPicPr>
             <a:picLocks noChangeAspect="1"/>
           </p:cNvPicPr>
           <p:nvPr/>
         </p:nvPicPr>
         <p:blipFill>
-          <a:blip r:embed="rId1"/>
+          <a:blip r:embed="rId3"/>
           <a:stretch>
             <a:fillRect/>
           </a:stretch>
         </p:blipFill>
         <p:spPr>
           <a:xfrm>
-            <a:off x="5394960" y="1645920"/>
-            <a:ext cx="6035040" cy="4389120"/>
+            <a:off x="4267200" y="701040"/>
+            <a:ext cx="4876800" cy="4419600"/>
           </a:xfrm>
           <a:prstGeom prst="ellipse">
             <a:avLst/>
@@ -6525,6 +6403,7 @@
         <a:solidFill>
           <a:srgbClr val="0B0F19"/>
         </a:solidFill>
+        <a:effectLst/>
       </p:bgPr>
     </p:bg>
     <p:spTree>
@@ -6560,6 +6439,13 @@
           </a:solidFill>
           <a:ln/>
         </p:spPr>
+        <p:txBody>
+          <a:bodyPr/>
+          <a:lstStyle/>
+          <a:p>
+            <a:endParaRPr lang="en-US"/>
+          </a:p>
+        </p:txBody>
       </p:sp>
       <p:sp>
         <p:nvSpPr>
@@ -6582,7 +6468,7 @@
           <a:bodyPr wrap="square" rtlCol="0" anchor="ctr"/>
           <a:lstStyle/>
           <a:p>
-            <a:pPr indent="0" marL="0">
+            <a:pPr marL="0" indent="0">
               <a:buNone/>
             </a:pPr>
             <a:r>
@@ -6618,7 +6504,7 @@
           <a:bodyPr wrap="square" rtlCol="0" anchor="ctr"/>
           <a:lstStyle/>
           <a:p>
-            <a:pPr indent="0" marL="0">
+            <a:pPr marL="0" indent="0">
               <a:buNone/>
             </a:pPr>
             <a:r>
@@ -6659,6 +6545,13 @@
             <a:prstDash val="solid"/>
           </a:ln>
         </p:spPr>
+        <p:txBody>
+          <a:bodyPr/>
+          <a:lstStyle/>
+          <a:p>
+            <a:endParaRPr lang="en-US"/>
+          </a:p>
+        </p:txBody>
       </p:sp>
       <p:sp>
         <p:nvSpPr>
@@ -6681,7 +6574,7 @@
           <a:bodyPr wrap="square" rtlCol="0" anchor="ctr"/>
           <a:lstStyle/>
           <a:p>
-            <a:pPr indent="0" marL="0">
+            <a:pPr marL="0" indent="0">
               <a:buNone/>
             </a:pPr>
             <a:r>
@@ -6717,7 +6610,7 @@
           <a:bodyPr wrap="square" rtlCol="0" anchor="ctr"/>
           <a:lstStyle/>
           <a:p>
-            <a:pPr indent="0" marL="0">
+            <a:pPr marL="0" indent="0">
               <a:lnSpc>
                 <a:spcPts val="1600"/>
               </a:lnSpc>
@@ -6734,16 +6627,16 @@
             <a:endParaRPr lang="en-US" sz="1100" dirty="0"/>
           </a:p>
           <a:p>
-            <a:pPr indent="0" marL="0">
-              <a:lnSpc>
-                <a:spcPts val="1600"/>
-              </a:lnSpc>
-              <a:buNone/>
-            </a:pPr>
-            <a:endParaRPr lang="en-US" sz="1100" dirty="0"/>
-          </a:p>
-          <a:p>
-            <a:pPr indent="0" marL="0">
+            <a:pPr marL="0" indent="0">
+              <a:lnSpc>
+                <a:spcPts val="1600"/>
+              </a:lnSpc>
+              <a:buNone/>
+            </a:pPr>
+            <a:endParaRPr lang="en-US" sz="1100" dirty="0"/>
+          </a:p>
+          <a:p>
+            <a:pPr marL="0" indent="0">
               <a:lnSpc>
                 <a:spcPts val="1600"/>
               </a:lnSpc>
@@ -6760,16 +6653,16 @@
             <a:endParaRPr lang="en-US" sz="1100" dirty="0"/>
           </a:p>
           <a:p>
-            <a:pPr indent="0" marL="0">
-              <a:lnSpc>
-                <a:spcPts val="1600"/>
-              </a:lnSpc>
-              <a:buNone/>
-            </a:pPr>
-            <a:endParaRPr lang="en-US" sz="1100" dirty="0"/>
-          </a:p>
-          <a:p>
-            <a:pPr indent="0" marL="0">
+            <a:pPr marL="0" indent="0">
+              <a:lnSpc>
+                <a:spcPts val="1600"/>
+              </a:lnSpc>
+              <a:buNone/>
+            </a:pPr>
+            <a:endParaRPr lang="en-US" sz="1100" dirty="0"/>
+          </a:p>
+          <a:p>
+            <a:pPr marL="0" indent="0">
               <a:lnSpc>
                 <a:spcPts val="1600"/>
               </a:lnSpc>
@@ -6786,16 +6679,16 @@
             <a:endParaRPr lang="en-US" sz="1100" dirty="0"/>
           </a:p>
           <a:p>
-            <a:pPr indent="0" marL="0">
-              <a:lnSpc>
-                <a:spcPts val="1600"/>
-              </a:lnSpc>
-              <a:buNone/>
-            </a:pPr>
-            <a:endParaRPr lang="en-US" sz="1100" dirty="0"/>
-          </a:p>
-          <a:p>
-            <a:pPr indent="0" marL="0">
+            <a:pPr marL="0" indent="0">
+              <a:lnSpc>
+                <a:spcPts val="1600"/>
+              </a:lnSpc>
+              <a:buNone/>
+            </a:pPr>
+            <a:endParaRPr lang="en-US" sz="1100" dirty="0"/>
+          </a:p>
+          <a:p>
+            <a:pPr marL="0" indent="0">
               <a:lnSpc>
                 <a:spcPts val="1600"/>
               </a:lnSpc>
@@ -6815,14 +6708,14 @@
       </p:sp>
       <p:pic>
         <p:nvPicPr>
-          <p:cNvPr id="8" name="Image 0" descr="C:\FUSION_HIGH_APP_1\FUSION_HIGH_APP_2.1\presentation_assets\screenshots\03_command_center.png">    </p:cNvPr>
+          <p:cNvPr id="8" name="Image 0" descr="C:\FUSION_HIGH_APP_1\FUSION_HIGH_APP_2.1\presentation_assets\screenshots\03_command_center.png"/>
           <p:cNvPicPr>
             <a:picLocks noChangeAspect="1"/>
           </p:cNvPicPr>
           <p:nvPr/>
         </p:nvPicPr>
         <p:blipFill>
-          <a:blip r:embed="rId1"/>
+          <a:blip r:embed="rId3"/>
           <a:stretch>
             <a:fillRect/>
           </a:stretch>
@@ -6853,6 +6746,7 @@
         <a:solidFill>
           <a:srgbClr val="0B0F19"/>
         </a:solidFill>
+        <a:effectLst/>
       </p:bgPr>
     </p:bg>
     <p:spTree>
@@ -6877,8 +6771,8 @@
         </p:nvSpPr>
         <p:spPr>
           <a:xfrm>
-            <a:off x="731520" y="457200"/>
-            <a:ext cx="10698480" cy="73152"/>
+            <a:off x="0" y="457200"/>
+            <a:ext cx="9144000" cy="274320"/>
           </a:xfrm>
           <a:prstGeom prst="rect">
             <a:avLst/>
@@ -6888,6 +6782,13 @@
           </a:solidFill>
           <a:ln/>
         </p:spPr>
+        <p:txBody>
+          <a:bodyPr/>
+          <a:lstStyle/>
+          <a:p>
+            <a:endParaRPr lang="en-US"/>
+          </a:p>
+        </p:txBody>
       </p:sp>
       <p:sp>
         <p:nvSpPr>
@@ -6897,8 +6798,8 @@
         </p:nvSpPr>
         <p:spPr>
           <a:xfrm>
-            <a:off x="731520" y="640080"/>
-            <a:ext cx="10698480" cy="457200"/>
+            <a:off x="0" y="731520"/>
+            <a:ext cx="9144000" cy="365760"/>
           </a:xfrm>
           <a:prstGeom prst="rect">
             <a:avLst/>
@@ -6910,7 +6811,7 @@
           <a:bodyPr wrap="square" rtlCol="0" anchor="ctr"/>
           <a:lstStyle/>
           <a:p>
-            <a:pPr indent="0" marL="0">
+            <a:pPr marL="0" indent="0">
               <a:buNone/>
             </a:pPr>
             <a:r>
@@ -6946,7 +6847,7 @@
           <a:bodyPr wrap="square" rtlCol="0" anchor="ctr"/>
           <a:lstStyle/>
           <a:p>
-            <a:pPr indent="0" marL="0">
+            <a:pPr marL="0" indent="0">
               <a:buNone/>
             </a:pPr>
             <a:r>
@@ -6969,8 +6870,8 @@
         </p:nvSpPr>
         <p:spPr>
           <a:xfrm>
-            <a:off x="731520" y="1645920"/>
-            <a:ext cx="4389120" cy="4389120"/>
+            <a:off x="99060" y="1554480"/>
+            <a:ext cx="4389120" cy="3589020"/>
           </a:xfrm>
           <a:prstGeom prst="roundRect">
             <a:avLst>
@@ -6987,6 +6888,13 @@
             <a:prstDash val="solid"/>
           </a:ln>
         </p:spPr>
+        <p:txBody>
+          <a:bodyPr/>
+          <a:lstStyle/>
+          <a:p>
+            <a:endParaRPr lang="en-US"/>
+          </a:p>
+        </p:txBody>
       </p:sp>
       <p:sp>
         <p:nvSpPr>
@@ -7009,7 +6917,7 @@
           <a:bodyPr wrap="square" rtlCol="0" anchor="ctr"/>
           <a:lstStyle/>
           <a:p>
-            <a:pPr indent="0" marL="0">
+            <a:pPr marL="0" indent="0">
               <a:buNone/>
             </a:pPr>
             <a:r>
@@ -7032,8 +6940,8 @@
         </p:nvSpPr>
         <p:spPr>
           <a:xfrm>
-            <a:off x="1005840" y="2286000"/>
-            <a:ext cx="3840480" cy="3474720"/>
+            <a:off x="274320" y="2194560"/>
+            <a:ext cx="3840480" cy="2758440"/>
           </a:xfrm>
           <a:prstGeom prst="rect">
             <a:avLst/>
@@ -7045,7 +6953,7 @@
           <a:bodyPr wrap="square" rtlCol="0" anchor="ctr"/>
           <a:lstStyle/>
           <a:p>
-            <a:pPr indent="0" marL="0">
+            <a:pPr marL="0" indent="0">
               <a:lnSpc>
                 <a:spcPts val="1600"/>
               </a:lnSpc>
@@ -7062,16 +6970,16 @@
             <a:endParaRPr lang="en-US" sz="1100" dirty="0"/>
           </a:p>
           <a:p>
-            <a:pPr indent="0" marL="0">
-              <a:lnSpc>
-                <a:spcPts val="1600"/>
-              </a:lnSpc>
-              <a:buNone/>
-            </a:pPr>
-            <a:endParaRPr lang="en-US" sz="1100" dirty="0"/>
-          </a:p>
-          <a:p>
-            <a:pPr indent="0" marL="0">
+            <a:pPr marL="0" indent="0">
+              <a:lnSpc>
+                <a:spcPts val="1600"/>
+              </a:lnSpc>
+              <a:buNone/>
+            </a:pPr>
+            <a:endParaRPr lang="en-US" sz="1100" dirty="0"/>
+          </a:p>
+          <a:p>
+            <a:pPr marL="0" indent="0">
               <a:lnSpc>
                 <a:spcPts val="1600"/>
               </a:lnSpc>
@@ -7088,16 +6996,16 @@
             <a:endParaRPr lang="en-US" sz="1100" dirty="0"/>
           </a:p>
           <a:p>
-            <a:pPr indent="0" marL="0">
-              <a:lnSpc>
-                <a:spcPts val="1600"/>
-              </a:lnSpc>
-              <a:buNone/>
-            </a:pPr>
-            <a:endParaRPr lang="en-US" sz="1100" dirty="0"/>
-          </a:p>
-          <a:p>
-            <a:pPr indent="0" marL="0">
+            <a:pPr marL="0" indent="0">
+              <a:lnSpc>
+                <a:spcPts val="1600"/>
+              </a:lnSpc>
+              <a:buNone/>
+            </a:pPr>
+            <a:endParaRPr lang="en-US" sz="1100" dirty="0"/>
+          </a:p>
+          <a:p>
+            <a:pPr marL="0" indent="0">
               <a:lnSpc>
                 <a:spcPts val="1600"/>
               </a:lnSpc>
@@ -7114,16 +7022,16 @@
             <a:endParaRPr lang="en-US" sz="1100" dirty="0"/>
           </a:p>
           <a:p>
-            <a:pPr indent="0" marL="0">
-              <a:lnSpc>
-                <a:spcPts val="1600"/>
-              </a:lnSpc>
-              <a:buNone/>
-            </a:pPr>
-            <a:endParaRPr lang="en-US" sz="1100" dirty="0"/>
-          </a:p>
-          <a:p>
-            <a:pPr indent="0" marL="0">
+            <a:pPr marL="0" indent="0">
+              <a:lnSpc>
+                <a:spcPts val="1600"/>
+              </a:lnSpc>
+              <a:buNone/>
+            </a:pPr>
+            <a:endParaRPr lang="en-US" sz="1100" dirty="0"/>
+          </a:p>
+          <a:p>
+            <a:pPr marL="0" indent="0">
               <a:lnSpc>
                 <a:spcPts val="1600"/>
               </a:lnSpc>
@@ -7141,30 +7049,6 @@
           </a:p>
         </p:txBody>
       </p:sp>
-      <p:pic>
-        <p:nvPicPr>
-          <p:cNvPr id="8" name="Image 0" descr="C:\FUSION_HIGH_APP_1\FUSION_HIGH_APP_2.1\presentation_assets\screenshots\04_user_directory.png">    </p:cNvPr>
-          <p:cNvPicPr>
-            <a:picLocks noChangeAspect="1"/>
-          </p:cNvPicPr>
-          <p:nvPr/>
-        </p:nvPicPr>
-        <p:blipFill>
-          <a:blip r:embed="rId1"/>
-          <a:stretch>
-            <a:fillRect/>
-          </a:stretch>
-        </p:blipFill>
-        <p:spPr>
-          <a:xfrm>
-            <a:off x="5394960" y="1645920"/>
-            <a:ext cx="6035040" cy="4389120"/>
-          </a:xfrm>
-          <a:prstGeom prst="ellipse">
-            <a:avLst/>
-          </a:prstGeom>
-        </p:spPr>
-      </p:pic>
     </p:spTree>
   </p:cSld>
   <p:clrMapOvr>
@@ -7181,6 +7065,7 @@
         <a:solidFill>
           <a:srgbClr val="0B0F19"/>
         </a:solidFill>
+        <a:effectLst/>
       </p:bgPr>
     </p:bg>
     <p:spTree>
@@ -7216,6 +7101,13 @@
           </a:solidFill>
           <a:ln/>
         </p:spPr>
+        <p:txBody>
+          <a:bodyPr/>
+          <a:lstStyle/>
+          <a:p>
+            <a:endParaRPr lang="en-US"/>
+          </a:p>
+        </p:txBody>
       </p:sp>
       <p:sp>
         <p:nvSpPr>
@@ -7238,7 +7130,7 @@
           <a:bodyPr wrap="square" rtlCol="0" anchor="ctr"/>
           <a:lstStyle/>
           <a:p>
-            <a:pPr indent="0" marL="0">
+            <a:pPr marL="0" indent="0">
               <a:buNone/>
             </a:pPr>
             <a:r>
@@ -7274,7 +7166,7 @@
           <a:bodyPr wrap="square" rtlCol="0" anchor="ctr"/>
           <a:lstStyle/>
           <a:p>
-            <a:pPr indent="0" marL="0">
+            <a:pPr marL="0" indent="0">
               <a:buNone/>
             </a:pPr>
             <a:r>
@@ -7315,6 +7207,13 @@
             <a:prstDash val="solid"/>
           </a:ln>
         </p:spPr>
+        <p:txBody>
+          <a:bodyPr/>
+          <a:lstStyle/>
+          <a:p>
+            <a:endParaRPr lang="en-US"/>
+          </a:p>
+        </p:txBody>
       </p:sp>
       <p:sp>
         <p:nvSpPr>
@@ -7337,7 +7236,7 @@
           <a:bodyPr wrap="square" rtlCol="0" anchor="ctr"/>
           <a:lstStyle/>
           <a:p>
-            <a:pPr indent="0" marL="0">
+            <a:pPr marL="0" indent="0">
               <a:buNone/>
             </a:pPr>
             <a:r>
@@ -7373,7 +7272,7 @@
           <a:bodyPr wrap="square" rtlCol="0" anchor="ctr"/>
           <a:lstStyle/>
           <a:p>
-            <a:pPr indent="0" marL="0">
+            <a:pPr marL="0" indent="0">
               <a:lnSpc>
                 <a:spcPts val="1600"/>
               </a:lnSpc>
@@ -7390,16 +7289,16 @@
             <a:endParaRPr lang="en-US" sz="1100" dirty="0"/>
           </a:p>
           <a:p>
-            <a:pPr indent="0" marL="0">
-              <a:lnSpc>
-                <a:spcPts val="1600"/>
-              </a:lnSpc>
-              <a:buNone/>
-            </a:pPr>
-            <a:endParaRPr lang="en-US" sz="1100" dirty="0"/>
-          </a:p>
-          <a:p>
-            <a:pPr indent="0" marL="0">
+            <a:pPr marL="0" indent="0">
+              <a:lnSpc>
+                <a:spcPts val="1600"/>
+              </a:lnSpc>
+              <a:buNone/>
+            </a:pPr>
+            <a:endParaRPr lang="en-US" sz="1100" dirty="0"/>
+          </a:p>
+          <a:p>
+            <a:pPr marL="0" indent="0">
               <a:lnSpc>
                 <a:spcPts val="1600"/>
               </a:lnSpc>
@@ -7416,16 +7315,16 @@
             <a:endParaRPr lang="en-US" sz="1100" dirty="0"/>
           </a:p>
           <a:p>
-            <a:pPr indent="0" marL="0">
-              <a:lnSpc>
-                <a:spcPts val="1600"/>
-              </a:lnSpc>
-              <a:buNone/>
-            </a:pPr>
-            <a:endParaRPr lang="en-US" sz="1100" dirty="0"/>
-          </a:p>
-          <a:p>
-            <a:pPr indent="0" marL="0">
+            <a:pPr marL="0" indent="0">
+              <a:lnSpc>
+                <a:spcPts val="1600"/>
+              </a:lnSpc>
+              <a:buNone/>
+            </a:pPr>
+            <a:endParaRPr lang="en-US" sz="1100" dirty="0"/>
+          </a:p>
+          <a:p>
+            <a:pPr marL="0" indent="0">
               <a:lnSpc>
                 <a:spcPts val="1600"/>
               </a:lnSpc>
@@ -7442,16 +7341,16 @@
             <a:endParaRPr lang="en-US" sz="1100" dirty="0"/>
           </a:p>
           <a:p>
-            <a:pPr indent="0" marL="0">
-              <a:lnSpc>
-                <a:spcPts val="1600"/>
-              </a:lnSpc>
-              <a:buNone/>
-            </a:pPr>
-            <a:endParaRPr lang="en-US" sz="1100" dirty="0"/>
-          </a:p>
-          <a:p>
-            <a:pPr indent="0" marL="0">
+            <a:pPr marL="0" indent="0">
+              <a:lnSpc>
+                <a:spcPts val="1600"/>
+              </a:lnSpc>
+              <a:buNone/>
+            </a:pPr>
+            <a:endParaRPr lang="en-US" sz="1100" dirty="0"/>
+          </a:p>
+          <a:p>
+            <a:pPr marL="0" indent="0">
               <a:lnSpc>
                 <a:spcPts val="1600"/>
               </a:lnSpc>
@@ -7471,14 +7370,14 @@
       </p:sp>
       <p:pic>
         <p:nvPicPr>
-          <p:cNvPr id="8" name="Image 0" descr="C:\FUSION_HIGH_APP_1\FUSION_HIGH_APP_2.1\presentation_assets\screenshots\05_inter_school.png">    </p:cNvPr>
+          <p:cNvPr id="8" name="Image 0" descr="C:\FUSION_HIGH_APP_1\FUSION_HIGH_APP_2.1\presentation_assets\screenshots\05_inter_school.png"/>
           <p:cNvPicPr>
             <a:picLocks noChangeAspect="1"/>
           </p:cNvPicPr>
           <p:nvPr/>
         </p:nvPicPr>
         <p:blipFill>
-          <a:blip r:embed="rId1"/>
+          <a:blip r:embed="rId3"/>
           <a:stretch>
             <a:fillRect/>
           </a:stretch>
@@ -7509,6 +7408,7 @@
         <a:solidFill>
           <a:srgbClr val="0B0F19"/>
         </a:solidFill>
+        <a:effectLst/>
       </p:bgPr>
     </p:bg>
     <p:spTree>
@@ -7544,6 +7444,13 @@
           </a:solidFill>
           <a:ln/>
         </p:spPr>
+        <p:txBody>
+          <a:bodyPr/>
+          <a:lstStyle/>
+          <a:p>
+            <a:endParaRPr lang="en-US"/>
+          </a:p>
+        </p:txBody>
       </p:sp>
       <p:sp>
         <p:nvSpPr>
@@ -7566,7 +7473,7 @@
           <a:bodyPr wrap="square" rtlCol="0" anchor="ctr"/>
           <a:lstStyle/>
           <a:p>
-            <a:pPr indent="0" marL="0">
+            <a:pPr marL="0" indent="0">
               <a:buNone/>
             </a:pPr>
             <a:r>
@@ -7602,7 +7509,7 @@
           <a:bodyPr wrap="square" rtlCol="0" anchor="ctr"/>
           <a:lstStyle/>
           <a:p>
-            <a:pPr indent="0" marL="0">
+            <a:pPr marL="0" indent="0">
               <a:buNone/>
             </a:pPr>
             <a:r>
@@ -7643,6 +7550,13 @@
             <a:prstDash val="solid"/>
           </a:ln>
         </p:spPr>
+        <p:txBody>
+          <a:bodyPr/>
+          <a:lstStyle/>
+          <a:p>
+            <a:endParaRPr lang="en-US"/>
+          </a:p>
+        </p:txBody>
       </p:sp>
       <p:sp>
         <p:nvSpPr>
@@ -7665,7 +7579,7 @@
           <a:bodyPr wrap="square" rtlCol="0" anchor="ctr"/>
           <a:lstStyle/>
           <a:p>
-            <a:pPr indent="0" marL="0">
+            <a:pPr marL="0" indent="0">
               <a:buNone/>
             </a:pPr>
             <a:r>
@@ -7701,7 +7615,7 @@
           <a:bodyPr wrap="square" rtlCol="0" anchor="ctr"/>
           <a:lstStyle/>
           <a:p>
-            <a:pPr indent="0" marL="0">
+            <a:pPr marL="0" indent="0">
               <a:lnSpc>
                 <a:spcPts val="1600"/>
               </a:lnSpc>
@@ -7718,16 +7632,16 @@
             <a:endParaRPr lang="en-US" sz="1100" dirty="0"/>
           </a:p>
           <a:p>
-            <a:pPr indent="0" marL="0">
-              <a:lnSpc>
-                <a:spcPts val="1600"/>
-              </a:lnSpc>
-              <a:buNone/>
-            </a:pPr>
-            <a:endParaRPr lang="en-US" sz="1100" dirty="0"/>
-          </a:p>
-          <a:p>
-            <a:pPr indent="0" marL="0">
+            <a:pPr marL="0" indent="0">
+              <a:lnSpc>
+                <a:spcPts val="1600"/>
+              </a:lnSpc>
+              <a:buNone/>
+            </a:pPr>
+            <a:endParaRPr lang="en-US" sz="1100" dirty="0"/>
+          </a:p>
+          <a:p>
+            <a:pPr marL="0" indent="0">
               <a:lnSpc>
                 <a:spcPts val="1600"/>
               </a:lnSpc>
@@ -7744,16 +7658,16 @@
             <a:endParaRPr lang="en-US" sz="1100" dirty="0"/>
           </a:p>
           <a:p>
-            <a:pPr indent="0" marL="0">
-              <a:lnSpc>
-                <a:spcPts val="1600"/>
-              </a:lnSpc>
-              <a:buNone/>
-            </a:pPr>
-            <a:endParaRPr lang="en-US" sz="1100" dirty="0"/>
-          </a:p>
-          <a:p>
-            <a:pPr indent="0" marL="0">
+            <a:pPr marL="0" indent="0">
+              <a:lnSpc>
+                <a:spcPts val="1600"/>
+              </a:lnSpc>
+              <a:buNone/>
+            </a:pPr>
+            <a:endParaRPr lang="en-US" sz="1100" dirty="0"/>
+          </a:p>
+          <a:p>
+            <a:pPr marL="0" indent="0">
               <a:lnSpc>
                 <a:spcPts val="1600"/>
               </a:lnSpc>
@@ -7770,16 +7684,16 @@
             <a:endParaRPr lang="en-US" sz="1100" dirty="0"/>
           </a:p>
           <a:p>
-            <a:pPr indent="0" marL="0">
-              <a:lnSpc>
-                <a:spcPts val="1600"/>
-              </a:lnSpc>
-              <a:buNone/>
-            </a:pPr>
-            <a:endParaRPr lang="en-US" sz="1100" dirty="0"/>
-          </a:p>
-          <a:p>
-            <a:pPr indent="0" marL="0">
+            <a:pPr marL="0" indent="0">
+              <a:lnSpc>
+                <a:spcPts val="1600"/>
+              </a:lnSpc>
+              <a:buNone/>
+            </a:pPr>
+            <a:endParaRPr lang="en-US" sz="1100" dirty="0"/>
+          </a:p>
+          <a:p>
+            <a:pPr marL="0" indent="0">
               <a:lnSpc>
                 <a:spcPts val="1600"/>
               </a:lnSpc>
@@ -7799,14 +7713,14 @@
       </p:sp>
       <p:pic>
         <p:nvPicPr>
-          <p:cNvPr id="8" name="Image 0" descr="C:\FUSION_HIGH_APP_1\FUSION_HIGH_APP_2.1\presentation_assets\screenshots\11_consultations.png">    </p:cNvPr>
+          <p:cNvPr id="8" name="Image 0" descr="C:\FUSION_HIGH_APP_1\FUSION_HIGH_APP_2.1\presentation_assets\screenshots\11_consultations.png"/>
           <p:cNvPicPr>
             <a:picLocks noChangeAspect="1"/>
           </p:cNvPicPr>
           <p:nvPr/>
         </p:nvPicPr>
         <p:blipFill>
-          <a:blip r:embed="rId1"/>
+          <a:blip r:embed="rId3"/>
           <a:stretch>
             <a:fillRect/>
           </a:stretch>
@@ -7837,6 +7751,7 @@
         <a:solidFill>
           <a:srgbClr val="0B0F19"/>
         </a:solidFill>
+        <a:effectLst/>
       </p:bgPr>
     </p:bg>
     <p:spTree>
@@ -7872,6 +7787,13 @@
           </a:solidFill>
           <a:ln/>
         </p:spPr>
+        <p:txBody>
+          <a:bodyPr/>
+          <a:lstStyle/>
+          <a:p>
+            <a:endParaRPr lang="en-US"/>
+          </a:p>
+        </p:txBody>
       </p:sp>
       <p:sp>
         <p:nvSpPr>
@@ -7894,7 +7816,7 @@
           <a:bodyPr wrap="square" rtlCol="0" anchor="ctr"/>
           <a:lstStyle/>
           <a:p>
-            <a:pPr indent="0" marL="0">
+            <a:pPr marL="0" indent="0">
               <a:buNone/>
             </a:pPr>
             <a:r>
@@ -7930,7 +7852,7 @@
           <a:bodyPr wrap="square" rtlCol="0" anchor="ctr"/>
           <a:lstStyle/>
           <a:p>
-            <a:pPr indent="0" marL="0">
+            <a:pPr marL="0" indent="0">
               <a:buNone/>
             </a:pPr>
             <a:r>
@@ -7971,6 +7893,13 @@
             <a:prstDash val="solid"/>
           </a:ln>
         </p:spPr>
+        <p:txBody>
+          <a:bodyPr/>
+          <a:lstStyle/>
+          <a:p>
+            <a:endParaRPr lang="en-US"/>
+          </a:p>
+        </p:txBody>
       </p:sp>
       <p:sp>
         <p:nvSpPr>
@@ -7993,7 +7922,7 @@
           <a:bodyPr wrap="square" rtlCol="0" anchor="ctr"/>
           <a:lstStyle/>
           <a:p>
-            <a:pPr indent="0" marL="0">
+            <a:pPr marL="0" indent="0">
               <a:buNone/>
             </a:pPr>
             <a:r>
@@ -8029,7 +7958,7 @@
           <a:bodyPr wrap="square" rtlCol="0" anchor="ctr"/>
           <a:lstStyle/>
           <a:p>
-            <a:pPr indent="0" marL="0">
+            <a:pPr marL="0" indent="0">
               <a:lnSpc>
                 <a:spcPts val="1600"/>
               </a:lnSpc>
@@ -8046,16 +7975,16 @@
             <a:endParaRPr lang="en-US" sz="1100" dirty="0"/>
           </a:p>
           <a:p>
-            <a:pPr indent="0" marL="0">
-              <a:lnSpc>
-                <a:spcPts val="1600"/>
-              </a:lnSpc>
-              <a:buNone/>
-            </a:pPr>
-            <a:endParaRPr lang="en-US" sz="1100" dirty="0"/>
-          </a:p>
-          <a:p>
-            <a:pPr indent="0" marL="0">
+            <a:pPr marL="0" indent="0">
+              <a:lnSpc>
+                <a:spcPts val="1600"/>
+              </a:lnSpc>
+              <a:buNone/>
+            </a:pPr>
+            <a:endParaRPr lang="en-US" sz="1100" dirty="0"/>
+          </a:p>
+          <a:p>
+            <a:pPr marL="0" indent="0">
               <a:lnSpc>
                 <a:spcPts val="1600"/>
               </a:lnSpc>
@@ -8072,16 +8001,16 @@
             <a:endParaRPr lang="en-US" sz="1100" dirty="0"/>
           </a:p>
           <a:p>
-            <a:pPr indent="0" marL="0">
-              <a:lnSpc>
-                <a:spcPts val="1600"/>
-              </a:lnSpc>
-              <a:buNone/>
-            </a:pPr>
-            <a:endParaRPr lang="en-US" sz="1100" dirty="0"/>
-          </a:p>
-          <a:p>
-            <a:pPr indent="0" marL="0">
+            <a:pPr marL="0" indent="0">
+              <a:lnSpc>
+                <a:spcPts val="1600"/>
+              </a:lnSpc>
+              <a:buNone/>
+            </a:pPr>
+            <a:endParaRPr lang="en-US" sz="1100" dirty="0"/>
+          </a:p>
+          <a:p>
+            <a:pPr marL="0" indent="0">
               <a:lnSpc>
                 <a:spcPts val="1600"/>
               </a:lnSpc>
@@ -8098,16 +8027,16 @@
             <a:endParaRPr lang="en-US" sz="1100" dirty="0"/>
           </a:p>
           <a:p>
-            <a:pPr indent="0" marL="0">
-              <a:lnSpc>
-                <a:spcPts val="1600"/>
-              </a:lnSpc>
-              <a:buNone/>
-            </a:pPr>
-            <a:endParaRPr lang="en-US" sz="1100" dirty="0"/>
-          </a:p>
-          <a:p>
-            <a:pPr indent="0" marL="0">
+            <a:pPr marL="0" indent="0">
+              <a:lnSpc>
+                <a:spcPts val="1600"/>
+              </a:lnSpc>
+              <a:buNone/>
+            </a:pPr>
+            <a:endParaRPr lang="en-US" sz="1100" dirty="0"/>
+          </a:p>
+          <a:p>
+            <a:pPr marL="0" indent="0">
               <a:lnSpc>
                 <a:spcPts val="1600"/>
               </a:lnSpc>
@@ -8127,14 +8056,14 @@
       </p:sp>
       <p:pic>
         <p:nvPicPr>
-          <p:cNvPr id="8" name="Image 0" descr="C:\FUSION_HIGH_APP_1\FUSION_HIGH_APP_2.1\presentation_assets\screenshots\12_caps_report_card.png">    </p:cNvPr>
+          <p:cNvPr id="8" name="Image 0" descr="C:\FUSION_HIGH_APP_1\FUSION_HIGH_APP_2.1\presentation_assets\screenshots\12_caps_report_card.png"/>
           <p:cNvPicPr>
             <a:picLocks noChangeAspect="1"/>
           </p:cNvPicPr>
           <p:nvPr/>
         </p:nvPicPr>
         <p:blipFill>
-          <a:blip r:embed="rId1"/>
+          <a:blip r:embed="rId3"/>
           <a:stretch>
             <a:fillRect/>
           </a:stretch>
@@ -8165,6 +8094,7 @@
         <a:solidFill>
           <a:srgbClr val="0B0F19"/>
         </a:solidFill>
+        <a:effectLst/>
       </p:bgPr>
     </p:bg>
     <p:spTree>
@@ -8200,6 +8130,13 @@
           </a:solidFill>
           <a:ln/>
         </p:spPr>
+        <p:txBody>
+          <a:bodyPr/>
+          <a:lstStyle/>
+          <a:p>
+            <a:endParaRPr lang="en-US"/>
+          </a:p>
+        </p:txBody>
       </p:sp>
       <p:sp>
         <p:nvSpPr>
@@ -8222,7 +8159,7 @@
           <a:bodyPr wrap="square" rtlCol="0" anchor="ctr"/>
           <a:lstStyle/>
           <a:p>
-            <a:pPr indent="0" marL="0">
+            <a:pPr marL="0" indent="0">
               <a:buNone/>
             </a:pPr>
             <a:r>
@@ -8258,7 +8195,7 @@
           <a:bodyPr wrap="square" rtlCol="0" anchor="ctr"/>
           <a:lstStyle/>
           <a:p>
-            <a:pPr indent="0" marL="0">
+            <a:pPr marL="0" indent="0">
               <a:buNone/>
             </a:pPr>
             <a:r>
@@ -8299,6 +8236,13 @@
             <a:prstDash val="solid"/>
           </a:ln>
         </p:spPr>
+        <p:txBody>
+          <a:bodyPr/>
+          <a:lstStyle/>
+          <a:p>
+            <a:endParaRPr lang="en-US"/>
+          </a:p>
+        </p:txBody>
       </p:sp>
       <p:sp>
         <p:nvSpPr>
@@ -8321,7 +8265,7 @@
           <a:bodyPr wrap="square" rtlCol="0" anchor="ctr"/>
           <a:lstStyle/>
           <a:p>
-            <a:pPr indent="0" marL="0">
+            <a:pPr marL="0" indent="0">
               <a:buNone/>
             </a:pPr>
             <a:r>
@@ -8357,7 +8301,7 @@
           <a:bodyPr wrap="square" rtlCol="0" anchor="ctr"/>
           <a:lstStyle/>
           <a:p>
-            <a:pPr indent="0" marL="0">
+            <a:pPr marL="0" indent="0">
               <a:lnSpc>
                 <a:spcPts val="1600"/>
               </a:lnSpc>
@@ -8374,16 +8318,16 @@
             <a:endParaRPr lang="en-US" sz="1100" dirty="0"/>
           </a:p>
           <a:p>
-            <a:pPr indent="0" marL="0">
-              <a:lnSpc>
-                <a:spcPts val="1600"/>
-              </a:lnSpc>
-              <a:buNone/>
-            </a:pPr>
-            <a:endParaRPr lang="en-US" sz="1100" dirty="0"/>
-          </a:p>
-          <a:p>
-            <a:pPr indent="0" marL="0">
+            <a:pPr marL="0" indent="0">
+              <a:lnSpc>
+                <a:spcPts val="1600"/>
+              </a:lnSpc>
+              <a:buNone/>
+            </a:pPr>
+            <a:endParaRPr lang="en-US" sz="1100" dirty="0"/>
+          </a:p>
+          <a:p>
+            <a:pPr marL="0" indent="0">
               <a:lnSpc>
                 <a:spcPts val="1600"/>
               </a:lnSpc>
@@ -8400,16 +8344,16 @@
             <a:endParaRPr lang="en-US" sz="1100" dirty="0"/>
           </a:p>
           <a:p>
-            <a:pPr indent="0" marL="0">
-              <a:lnSpc>
-                <a:spcPts val="1600"/>
-              </a:lnSpc>
-              <a:buNone/>
-            </a:pPr>
-            <a:endParaRPr lang="en-US" sz="1100" dirty="0"/>
-          </a:p>
-          <a:p>
-            <a:pPr indent="0" marL="0">
+            <a:pPr marL="0" indent="0">
+              <a:lnSpc>
+                <a:spcPts val="1600"/>
+              </a:lnSpc>
+              <a:buNone/>
+            </a:pPr>
+            <a:endParaRPr lang="en-US" sz="1100" dirty="0"/>
+          </a:p>
+          <a:p>
+            <a:pPr marL="0" indent="0">
               <a:lnSpc>
                 <a:spcPts val="1600"/>
               </a:lnSpc>
@@ -8426,16 +8370,16 @@
             <a:endParaRPr lang="en-US" sz="1100" dirty="0"/>
           </a:p>
           <a:p>
-            <a:pPr indent="0" marL="0">
-              <a:lnSpc>
-                <a:spcPts val="1600"/>
-              </a:lnSpc>
-              <a:buNone/>
-            </a:pPr>
-            <a:endParaRPr lang="en-US" sz="1100" dirty="0"/>
-          </a:p>
-          <a:p>
-            <a:pPr indent="0" marL="0">
+            <a:pPr marL="0" indent="0">
+              <a:lnSpc>
+                <a:spcPts val="1600"/>
+              </a:lnSpc>
+              <a:buNone/>
+            </a:pPr>
+            <a:endParaRPr lang="en-US" sz="1100" dirty="0"/>
+          </a:p>
+          <a:p>
+            <a:pPr marL="0" indent="0">
               <a:lnSpc>
                 <a:spcPts val="1600"/>
               </a:lnSpc>
@@ -8455,14 +8399,14 @@
       </p:sp>
       <p:pic>
         <p:nvPicPr>
-          <p:cNvPr id="8" name="Image 0" descr="C:\FUSION_HIGH_APP_1\FUSION_HIGH_APP_2.1\presentation_assets\screenshots\06_academic_audits.png">    </p:cNvPr>
+          <p:cNvPr id="8" name="Image 0" descr="C:\FUSION_HIGH_APP_1\FUSION_HIGH_APP_2.1\presentation_assets\screenshots\06_academic_audits.png"/>
           <p:cNvPicPr>
             <a:picLocks noChangeAspect="1"/>
           </p:cNvPicPr>
           <p:nvPr/>
         </p:nvPicPr>
         <p:blipFill>
-          <a:blip r:embed="rId1"/>
+          <a:blip r:embed="rId3"/>
           <a:stretch>
             <a:fillRect/>
           </a:stretch>
@@ -8778,4 +8722,319 @@
     </a:ext>
   </a:extLst>
 </a:theme>
+</file>
+
+<file path=ppt/theme/theme2.xml><?xml version="1.0" encoding="utf-8"?>
+<a:theme xmlns:a="http://schemas.openxmlformats.org/drawingml/2006/main" name="Office Theme">
+  <a:themeElements>
+    <a:clrScheme name="Office">
+      <a:dk1>
+        <a:sysClr val="windowText" lastClr="000000"/>
+      </a:dk1>
+      <a:lt1>
+        <a:sysClr val="window" lastClr="FFFFFF"/>
+      </a:lt1>
+      <a:dk2>
+        <a:srgbClr val="0E2841"/>
+      </a:dk2>
+      <a:lt2>
+        <a:srgbClr val="E8E8E8"/>
+      </a:lt2>
+      <a:accent1>
+        <a:srgbClr val="156082"/>
+      </a:accent1>
+      <a:accent2>
+        <a:srgbClr val="E97132"/>
+      </a:accent2>
+      <a:accent3>
+        <a:srgbClr val="196B24"/>
+      </a:accent3>
+      <a:accent4>
+        <a:srgbClr val="0F9ED5"/>
+      </a:accent4>
+      <a:accent5>
+        <a:srgbClr val="A02B93"/>
+      </a:accent5>
+      <a:accent6>
+        <a:srgbClr val="4EA72E"/>
+      </a:accent6>
+      <a:hlink>
+        <a:srgbClr val="467886"/>
+      </a:hlink>
+      <a:folHlink>
+        <a:srgbClr val="96607D"/>
+      </a:folHlink>
+    </a:clrScheme>
+    <a:fontScheme name="Office">
+      <a:majorFont>
+        <a:latin typeface="Aptos Display" panose="02110004020202020204"/>
+        <a:ea typeface=""/>
+        <a:cs typeface=""/>
+        <a:font script="Jpan" typeface="游ゴシック Light"/>
+        <a:font script="Hang" typeface="맑은 고딕"/>
+        <a:font script="Hans" typeface="等线 Light"/>
+        <a:font script="Hant" typeface="新細明體"/>
+        <a:font script="Arab" typeface="Times New Roman"/>
+        <a:font script="Hebr" typeface="Times New Roman"/>
+        <a:font script="Thai" typeface="Angsana New"/>
+        <a:font script="Ethi" typeface="Nyala"/>
+        <a:font script="Beng" typeface="Vrinda"/>
+        <a:font script="Gujr" typeface="Shruti"/>
+        <a:font script="Khmr" typeface="MoolBoran"/>
+        <a:font script="Knda" typeface="Tunga"/>
+        <a:font script="Guru" typeface="Raavi"/>
+        <a:font script="Cans" typeface="Euphemia"/>
+        <a:font script="Cher" typeface="Plantagenet Cherokee"/>
+        <a:font script="Yiii" typeface="Microsoft Yi Baiti"/>
+        <a:font script="Tibt" typeface="Microsoft Himalaya"/>
+        <a:font script="Thaa" typeface="MV Boli"/>
+        <a:font script="Deva" typeface="Mangal"/>
+        <a:font script="Telu" typeface="Gautami"/>
+        <a:font script="Taml" typeface="Latha"/>
+        <a:font script="Syrc" typeface="Estrangelo Edessa"/>
+        <a:font script="Orya" typeface="Kalinga"/>
+        <a:font script="Mlym" typeface="Kartika"/>
+        <a:font script="Laoo" typeface="DokChampa"/>
+        <a:font script="Sinh" typeface="Iskoola Pota"/>
+        <a:font script="Mong" typeface="Mongolian Baiti"/>
+        <a:font script="Viet" typeface="Times New Roman"/>
+        <a:font script="Uigh" typeface="Microsoft Uighur"/>
+        <a:font script="Geor" typeface="Sylfaen"/>
+        <a:font script="Armn" typeface="Arial"/>
+        <a:font script="Bugi" typeface="Leelawadee UI"/>
+        <a:font script="Bopo" typeface="Microsoft JhengHei"/>
+        <a:font script="Java" typeface="Javanese Text"/>
+        <a:font script="Lisu" typeface="Segoe UI"/>
+        <a:font script="Mymr" typeface="Myanmar Text"/>
+        <a:font script="Nkoo" typeface="Ebrima"/>
+        <a:font script="Olck" typeface="Nirmala UI"/>
+        <a:font script="Osma" typeface="Ebrima"/>
+        <a:font script="Phag" typeface="Phagspa"/>
+        <a:font script="Syrn" typeface="Estrangelo Edessa"/>
+        <a:font script="Syrj" typeface="Estrangelo Edessa"/>
+        <a:font script="Syre" typeface="Estrangelo Edessa"/>
+        <a:font script="Sora" typeface="Nirmala UI"/>
+        <a:font script="Tale" typeface="Microsoft Tai Le"/>
+        <a:font script="Talu" typeface="Microsoft New Tai Lue"/>
+        <a:font script="Tfng" typeface="Ebrima"/>
+      </a:majorFont>
+      <a:minorFont>
+        <a:latin typeface="Aptos" panose="02110004020202020204"/>
+        <a:ea typeface=""/>
+        <a:cs typeface=""/>
+        <a:font script="Jpan" typeface="游ゴシック"/>
+        <a:font script="Hang" typeface="맑은 고딕"/>
+        <a:font script="Hans" typeface="等线"/>
+        <a:font script="Hant" typeface="新細明體"/>
+        <a:font script="Arab" typeface="Arial"/>
+        <a:font script="Hebr" typeface="Arial"/>
+        <a:font script="Thai" typeface="Cordia New"/>
+        <a:font script="Ethi" typeface="Nyala"/>
+        <a:font script="Beng" typeface="Vrinda"/>
+        <a:font script="Gujr" typeface="Shruti"/>
+        <a:font script="Khmr" typeface="DaunPenh"/>
+        <a:font script="Knda" typeface="Tunga"/>
+        <a:font script="Guru" typeface="Raavi"/>
+        <a:font script="Cans" typeface="Euphemia"/>
+        <a:font script="Cher" typeface="Plantagenet Cherokee"/>
+        <a:font script="Yiii" typeface="Microsoft Yi Baiti"/>
+        <a:font script="Tibt" typeface="Microsoft Himalaya"/>
+        <a:font script="Thaa" typeface="MV Boli"/>
+        <a:font script="Deva" typeface="Mangal"/>
+        <a:font script="Telu" typeface="Gautami"/>
+        <a:font script="Taml" typeface="Latha"/>
+        <a:font script="Syrc" typeface="Estrangelo Edessa"/>
+        <a:font script="Orya" typeface="Kalinga"/>
+        <a:font script="Mlym" typeface="Kartika"/>
+        <a:font script="Laoo" typeface="DokChampa"/>
+        <a:font script="Sinh" typeface="Iskoola Pota"/>
+        <a:font script="Mong" typeface="Mongolian Baiti"/>
+        <a:font script="Viet" typeface="Arial"/>
+        <a:font script="Uigh" typeface="Microsoft Uighur"/>
+        <a:font script="Geor" typeface="Sylfaen"/>
+        <a:font script="Armn" typeface="Arial"/>
+        <a:font script="Bugi" typeface="Leelawadee UI"/>
+        <a:font script="Bopo" typeface="Microsoft JhengHei"/>
+        <a:font script="Java" typeface="Javanese Text"/>
+        <a:font script="Lisu" typeface="Segoe UI"/>
+        <a:font script="Mymr" typeface="Myanmar Text"/>
+        <a:font script="Nkoo" typeface="Ebrima"/>
+        <a:font script="Olck" typeface="Nirmala UI"/>
+        <a:font script="Osma" typeface="Ebrima"/>
+        <a:font script="Phag" typeface="Phagspa"/>
+        <a:font script="Syrn" typeface="Estrangelo Edessa"/>
+        <a:font script="Syrj" typeface="Estrangelo Edessa"/>
+        <a:font script="Syre" typeface="Estrangelo Edessa"/>
+        <a:font script="Sora" typeface="Nirmala UI"/>
+        <a:font script="Tale" typeface="Microsoft Tai Le"/>
+        <a:font script="Talu" typeface="Microsoft New Tai Lue"/>
+        <a:font script="Tfng" typeface="Ebrima"/>
+      </a:minorFont>
+    </a:fontScheme>
+    <a:fmtScheme name="Office">
+      <a:fillStyleLst>
+        <a:solidFill>
+          <a:schemeClr val="phClr"/>
+        </a:solidFill>
+        <a:gradFill rotWithShape="1">
+          <a:gsLst>
+            <a:gs pos="0">
+              <a:schemeClr val="phClr">
+                <a:lumMod val="110000"/>
+                <a:satMod val="105000"/>
+                <a:tint val="67000"/>
+              </a:schemeClr>
+            </a:gs>
+            <a:gs pos="50000">
+              <a:schemeClr val="phClr">
+                <a:lumMod val="105000"/>
+                <a:satMod val="103000"/>
+                <a:tint val="73000"/>
+              </a:schemeClr>
+            </a:gs>
+            <a:gs pos="100000">
+              <a:schemeClr val="phClr">
+                <a:lumMod val="105000"/>
+                <a:satMod val="109000"/>
+                <a:tint val="81000"/>
+              </a:schemeClr>
+            </a:gs>
+          </a:gsLst>
+          <a:lin ang="5400000" scaled="0"/>
+        </a:gradFill>
+        <a:gradFill rotWithShape="1">
+          <a:gsLst>
+            <a:gs pos="0">
+              <a:schemeClr val="phClr">
+                <a:satMod val="103000"/>
+                <a:lumMod val="102000"/>
+                <a:tint val="94000"/>
+              </a:schemeClr>
+            </a:gs>
+            <a:gs pos="50000">
+              <a:schemeClr val="phClr">
+                <a:satMod val="110000"/>
+                <a:lumMod val="100000"/>
+                <a:shade val="100000"/>
+              </a:schemeClr>
+            </a:gs>
+            <a:gs pos="100000">
+              <a:schemeClr val="phClr">
+                <a:lumMod val="99000"/>
+                <a:satMod val="120000"/>
+                <a:shade val="78000"/>
+              </a:schemeClr>
+            </a:gs>
+          </a:gsLst>
+          <a:lin ang="5400000" scaled="0"/>
+        </a:gradFill>
+      </a:fillStyleLst>
+      <a:lnStyleLst>
+        <a:ln w="12700" cap="flat" cmpd="sng" algn="ctr">
+          <a:solidFill>
+            <a:schemeClr val="phClr"/>
+          </a:solidFill>
+          <a:prstDash val="solid"/>
+          <a:miter lim="800000"/>
+        </a:ln>
+        <a:ln w="19050" cap="flat" cmpd="sng" algn="ctr">
+          <a:solidFill>
+            <a:schemeClr val="phClr"/>
+          </a:solidFill>
+          <a:prstDash val="solid"/>
+          <a:miter lim="800000"/>
+        </a:ln>
+        <a:ln w="25400" cap="flat" cmpd="sng" algn="ctr">
+          <a:solidFill>
+            <a:schemeClr val="phClr"/>
+          </a:solidFill>
+          <a:prstDash val="solid"/>
+          <a:miter lim="800000"/>
+        </a:ln>
+      </a:lnStyleLst>
+      <a:effectStyleLst>
+        <a:effectStyle>
+          <a:effectLst/>
+        </a:effectStyle>
+        <a:effectStyle>
+          <a:effectLst/>
+        </a:effectStyle>
+        <a:effectStyle>
+          <a:effectLst>
+            <a:outerShdw blurRad="57150" dist="19050" dir="5400000" algn="ctr" rotWithShape="0">
+              <a:srgbClr val="000000">
+                <a:alpha val="63000"/>
+              </a:srgbClr>
+            </a:outerShdw>
+          </a:effectLst>
+        </a:effectStyle>
+      </a:effectStyleLst>
+      <a:bgFillStyleLst>
+        <a:solidFill>
+          <a:schemeClr val="phClr"/>
+        </a:solidFill>
+        <a:solidFill>
+          <a:schemeClr val="phClr">
+            <a:tint val="95000"/>
+            <a:satMod val="170000"/>
+          </a:schemeClr>
+        </a:solidFill>
+        <a:gradFill rotWithShape="1">
+          <a:gsLst>
+            <a:gs pos="0">
+              <a:schemeClr val="phClr">
+                <a:tint val="93000"/>
+                <a:satMod val="150000"/>
+                <a:shade val="98000"/>
+                <a:lumMod val="102000"/>
+              </a:schemeClr>
+            </a:gs>
+            <a:gs pos="50000">
+              <a:schemeClr val="phClr">
+                <a:tint val="98000"/>
+                <a:satMod val="130000"/>
+                <a:shade val="90000"/>
+                <a:lumMod val="103000"/>
+              </a:schemeClr>
+            </a:gs>
+            <a:gs pos="100000">
+              <a:schemeClr val="phClr">
+                <a:shade val="63000"/>
+                <a:satMod val="120000"/>
+              </a:schemeClr>
+            </a:gs>
+          </a:gsLst>
+          <a:lin ang="5400000" scaled="0"/>
+        </a:gradFill>
+      </a:bgFillStyleLst>
+    </a:fmtScheme>
+  </a:themeElements>
+  <a:objectDefaults>
+    <a:lnDef>
+      <a:spPr/>
+      <a:bodyPr/>
+      <a:lstStyle/>
+      <a:style>
+        <a:lnRef idx="2">
+          <a:schemeClr val="accent1"/>
+        </a:lnRef>
+        <a:fillRef idx="0">
+          <a:schemeClr val="accent1"/>
+        </a:fillRef>
+        <a:effectRef idx="1">
+          <a:schemeClr val="accent1"/>
+        </a:effectRef>
+        <a:fontRef idx="minor">
+          <a:schemeClr val="tx1"/>
+        </a:fontRef>
+      </a:style>
+    </a:lnDef>
+  </a:objectDefaults>
+  <a:extraClrSchemeLst/>
+  <a:extLst>
+    <a:ext uri="{05A4C25C-085E-4340-85A3-A5531E510DB2}">
+      <thm15:themeFamily xmlns:thm15="http://schemas.microsoft.com/office/thememl/2012/main" name="Office Theme" id="{2E142A2C-CD16-42D6-873A-C26D2A0506FA}" vid="{1BDDFF52-6CD6-40A5-AB3C-68EB2F1E4D0A}"/>
+    </a:ext>
+  </a:extLst>
+</a:theme>
 </file>
</xml_diff>